<commit_message>
Redesign poster with section boxes, better spacing and typography
</commit_message>
<xml_diff>
--- a/docs/team046poster.pptx
+++ b/docs/team046poster.pptx
@@ -3081,6 +3081,14 @@
 <file path=ppt/slides/slide1.xml><?xml version="1.0" encoding="utf-8"?>
 <p:sld xmlns:a="http://schemas.openxmlformats.org/drawingml/2006/main" xmlns:p="http://schemas.openxmlformats.org/presentationml/2006/main" xmlns:r="http://schemas.openxmlformats.org/officeDocument/2006/relationships">
   <p:cSld>
+    <p:bg>
+      <p:bgPr>
+        <a:solidFill>
+          <a:srgbClr val="FFFFFF"/>
+        </a:solidFill>
+        <a:effectLst/>
+      </p:bgPr>
+    </p:bg>
     <p:spTree>
       <p:nvGrpSpPr>
         <p:cNvPr id="1" name=""/>
@@ -3097,13 +3105,13 @@
         <p:spPr>
           <a:xfrm>
             <a:off x="0" y="0"/>
-            <a:ext cx="27432000" cy="2926080"/>
+            <a:ext cx="27432000" cy="3108960"/>
           </a:xfrm>
           <a:prstGeom prst="rect">
             <a:avLst/>
           </a:prstGeom>
           <a:solidFill>
-            <a:srgbClr val="C0392B"/>
+            <a:srgbClr val="B71C1C"/>
           </a:solidFill>
           <a:ln>
             <a:noFill/>
@@ -3133,160 +3141,20 @@
       </p:sp>
       <p:sp>
         <p:nvSpPr>
-          <p:cNvPr id="3" name="TextBox 2"/>
-          <p:cNvSpPr txBox="1"/>
-          <p:nvPr/>
-        </p:nvSpPr>
-        <p:spPr>
-          <a:xfrm>
-            <a:off x="731520" y="457200"/>
-            <a:ext cx="25968960" cy="1280160"/>
-          </a:xfrm>
-          <a:prstGeom prst="rect">
-            <a:avLst/>
-          </a:prstGeom>
-          <a:noFill/>
-        </p:spPr>
-        <p:txBody>
-          <a:bodyPr wrap="square">
-            <a:spAutoFit/>
-          </a:bodyPr>
-          <a:lstStyle/>
-          <a:p>
-            <a:pPr algn="ctr">
-              <a:defRPr sz="5200" b="1">
-                <a:solidFill>
-                  <a:srgbClr val="FFFFFF"/>
-                </a:solidFill>
-              </a:defRPr>
-            </a:pPr>
-            <a:r>
-              <a:t>Ignition Insights: Explaining and Forecasting Urban Fire Risk</a:t>
-            </a:r>
-          </a:p>
-        </p:txBody>
-      </p:sp>
-      <p:sp>
-        <p:nvSpPr>
-          <p:cNvPr id="4" name="TextBox 3"/>
-          <p:cNvSpPr txBox="1"/>
-          <p:nvPr/>
-        </p:nvSpPr>
-        <p:spPr>
-          <a:xfrm>
-            <a:off x="731520" y="1828800"/>
-            <a:ext cx="25968960" cy="548640"/>
-          </a:xfrm>
-          <a:prstGeom prst="rect">
-            <a:avLst/>
-          </a:prstGeom>
-          <a:noFill/>
-        </p:spPr>
-        <p:txBody>
-          <a:bodyPr wrap="square">
-            <a:spAutoFit/>
-          </a:bodyPr>
-          <a:lstStyle/>
-          <a:p>
-            <a:pPr algn="ctr">
-              <a:defRPr sz="2600" b="0">
-                <a:solidFill>
-                  <a:srgbClr val="FFFFFF"/>
-                </a:solidFill>
-              </a:defRPr>
-            </a:pPr>
-            <a:r>
-              <a:t>Team 46:  Vishruth Anand  |  Vineeth Nareddy  |  Rian Rahman  |  James Reilly  |  Jayanth Vennamreddy</a:t>
-            </a:r>
-          </a:p>
-        </p:txBody>
-      </p:sp>
-      <p:sp>
-        <p:nvSpPr>
-          <p:cNvPr id="5" name="TextBox 4"/>
-          <p:cNvSpPr txBox="1"/>
-          <p:nvPr/>
-        </p:nvSpPr>
-        <p:spPr>
-          <a:xfrm>
-            <a:off x="731520" y="2331720"/>
-            <a:ext cx="25968960" cy="457200"/>
-          </a:xfrm>
-          <a:prstGeom prst="rect">
-            <a:avLst/>
-          </a:prstGeom>
-          <a:noFill/>
-        </p:spPr>
-        <p:txBody>
-          <a:bodyPr wrap="square">
-            <a:spAutoFit/>
-          </a:bodyPr>
-          <a:lstStyle/>
-          <a:p>
-            <a:pPr algn="ctr">
-              <a:defRPr sz="2200" b="0">
-                <a:solidFill>
-                  <a:srgbClr val="FFCCCC"/>
-                </a:solidFill>
-              </a:defRPr>
-            </a:pPr>
-            <a:r>
-              <a:t>Georgia Institute of Technology  —  CSE 6242 Data and Visual Analytics</a:t>
-            </a:r>
-          </a:p>
-        </p:txBody>
-      </p:sp>
-      <p:sp>
-        <p:nvSpPr>
-          <p:cNvPr id="6" name="TextBox 5"/>
-          <p:cNvSpPr txBox="1"/>
-          <p:nvPr/>
-        </p:nvSpPr>
-        <p:spPr>
-          <a:xfrm>
-            <a:off x="548640" y="3291840"/>
-            <a:ext cx="12618720" cy="502920"/>
-          </a:xfrm>
-          <a:prstGeom prst="rect">
-            <a:avLst/>
-          </a:prstGeom>
-          <a:noFill/>
-        </p:spPr>
-        <p:txBody>
-          <a:bodyPr wrap="square">
-            <a:spAutoFit/>
-          </a:bodyPr>
-          <a:lstStyle/>
-          <a:p>
-            <a:pPr algn="l">
-              <a:defRPr sz="2800" b="1">
-                <a:solidFill>
-                  <a:srgbClr val="C0392B"/>
-                </a:solidFill>
-              </a:defRPr>
-            </a:pPr>
-            <a:r>
-              <a:t>Introduction</a:t>
-            </a:r>
-          </a:p>
-        </p:txBody>
-      </p:sp>
-      <p:sp>
-        <p:nvSpPr>
-          <p:cNvPr id="7" name="Rectangle 6"/>
+          <p:cNvPr id="3" name="Rectangle 2"/>
           <p:cNvSpPr/>
           <p:nvPr/>
         </p:nvSpPr>
         <p:spPr>
           <a:xfrm>
-            <a:off x="548640" y="3749040"/>
-            <a:ext cx="12618720" cy="36576"/>
+            <a:off x="0" y="2926080"/>
+            <a:ext cx="27432000" cy="182880"/>
           </a:xfrm>
           <a:prstGeom prst="rect">
             <a:avLst/>
           </a:prstGeom>
           <a:solidFill>
-            <a:srgbClr val="C0392B"/>
+            <a:srgbClr val="8B0A0A"/>
           </a:solidFill>
           <a:ln>
             <a:noFill/>
@@ -3316,14 +3184,14 @@
       </p:sp>
       <p:sp>
         <p:nvSpPr>
-          <p:cNvPr id="8" name="TextBox 7"/>
+          <p:cNvPr id="4" name="TextBox 3"/>
           <p:cNvSpPr txBox="1"/>
           <p:nvPr/>
         </p:nvSpPr>
         <p:spPr>
           <a:xfrm>
-            <a:off x="548640" y="3840480"/>
-            <a:ext cx="12618720" cy="2743200"/>
+            <a:off x="914400" y="411480"/>
+            <a:ext cx="25603200" cy="1188720"/>
           </a:xfrm>
           <a:prstGeom prst="rect">
             <a:avLst/>
@@ -3331,79 +3199,35 @@
           <a:noFill/>
         </p:spPr>
         <p:txBody>
-          <a:bodyPr wrap="square">
+          <a:bodyPr wrap="none">
             <a:spAutoFit/>
           </a:bodyPr>
           <a:lstStyle/>
           <a:p>
-            <a:pPr algn="l">
-              <a:defRPr sz="2000" b="0">
-                <a:solidFill>
-                  <a:srgbClr val="444444"/>
-                </a:solidFill>
+            <a:pPr algn="ctr">
+              <a:defRPr sz="6000" b="1">
+                <a:solidFill>
+                  <a:srgbClr val="FFFFFF"/>
+                </a:solidFill>
+                <a:latin typeface="Calibri"/>
               </a:defRPr>
             </a:pPr>
             <a:r>
-              <a:t>•  Fire departments make staffing and readiness decisions under uncertainty, yet fire incidents are not uniformly distributed across a city.</a:t>
-            </a:r>
-          </a:p>
-          <a:p>
-            <a:pPr>
-              <a:spcBef>
-                <a:spcPts val="800"/>
-              </a:spcBef>
-              <a:defRPr sz="2000" b="0">
-                <a:solidFill>
-                  <a:srgbClr val="444444"/>
-                </a:solidFill>
-              </a:defRPr>
-            </a:pPr>
-            <a:r>
-              <a:t>•  Existing tools show what happened but not where risk is concentrated, how it changes over time, or why a model flags a particular area.</a:t>
-            </a:r>
-          </a:p>
-          <a:p>
-            <a:pPr>
-              <a:spcBef>
-                <a:spcPts val="800"/>
-              </a:spcBef>
-              <a:defRPr sz="2000" b="0">
-                <a:solidFill>
-                  <a:srgbClr val="444444"/>
-                </a:solidFill>
-              </a:defRPr>
-            </a:pPr>
-            <a:r>
-              <a:t>•  We built an end-to-end system that forecasts short-horizon fire risk across a 1 km grid of Atlanta and explains each prediction.</a:t>
-            </a:r>
-          </a:p>
-          <a:p>
-            <a:pPr>
-              <a:spcBef>
-                <a:spcPts val="800"/>
-              </a:spcBef>
-              <a:defRPr sz="2000" b="0">
-                <a:solidFill>
-                  <a:srgbClr val="444444"/>
-                </a:solidFill>
-              </a:defRPr>
-            </a:pPr>
-            <a:r>
-              <a:t>•  The goal is relative risk ranking and explanation, not perfect prediction of individual fires (0.5% positive rate).</a:t>
-            </a:r>
-          </a:p>
-        </p:txBody>
-      </p:sp>
-      <p:sp>
-        <p:nvSpPr>
-          <p:cNvPr id="9" name="TextBox 8"/>
+              <a:t>Ignition Insights</a:t>
+            </a:r>
+          </a:p>
+        </p:txBody>
+      </p:sp>
+      <p:sp>
+        <p:nvSpPr>
+          <p:cNvPr id="5" name="TextBox 4"/>
           <p:cNvSpPr txBox="1"/>
           <p:nvPr/>
         </p:nvSpPr>
         <p:spPr>
           <a:xfrm>
-            <a:off x="548640" y="6766560"/>
-            <a:ext cx="12618720" cy="502920"/>
+            <a:off x="914400" y="1463040"/>
+            <a:ext cx="25603200" cy="640080"/>
           </a:xfrm>
           <a:prstGeom prst="rect">
             <a:avLst/>
@@ -3411,43 +3235,97 @@
           <a:noFill/>
         </p:spPr>
         <p:txBody>
-          <a:bodyPr wrap="square">
+          <a:bodyPr wrap="none">
             <a:spAutoFit/>
           </a:bodyPr>
           <a:lstStyle/>
           <a:p>
-            <a:pPr algn="l">
-              <a:defRPr sz="2800" b="1">
-                <a:solidFill>
-                  <a:srgbClr val="C0392B"/>
-                </a:solidFill>
+            <a:pPr algn="ctr">
+              <a:defRPr sz="3600" b="0">
+                <a:solidFill>
+                  <a:srgbClr val="FFDDDD"/>
+                </a:solidFill>
+                <a:latin typeface="Calibri"/>
               </a:defRPr>
             </a:pPr>
             <a:r>
-              <a:t>Data</a:t>
-            </a:r>
-          </a:p>
-        </p:txBody>
-      </p:sp>
-      <p:sp>
-        <p:nvSpPr>
-          <p:cNvPr id="10" name="Rectangle 9"/>
-          <p:cNvSpPr/>
+              <a:t>Explaining and Forecasting Urban Fire Risk</a:t>
+            </a:r>
+          </a:p>
+        </p:txBody>
+      </p:sp>
+      <p:sp>
+        <p:nvSpPr>
+          <p:cNvPr id="6" name="TextBox 5"/>
+          <p:cNvSpPr txBox="1"/>
           <p:nvPr/>
         </p:nvSpPr>
         <p:spPr>
           <a:xfrm>
-            <a:off x="548640" y="7223760"/>
-            <a:ext cx="12618720" cy="36576"/>
+            <a:off x="914400" y="2148840"/>
+            <a:ext cx="25603200" cy="640080"/>
           </a:xfrm>
           <a:prstGeom prst="rect">
             <a:avLst/>
           </a:prstGeom>
+          <a:noFill/>
+        </p:spPr>
+        <p:txBody>
+          <a:bodyPr wrap="none">
+            <a:spAutoFit/>
+          </a:bodyPr>
+          <a:lstStyle/>
+          <a:p>
+            <a:pPr algn="ctr">
+              <a:defRPr sz="2400">
+                <a:solidFill>
+                  <a:srgbClr val="FFFFFF"/>
+                </a:solidFill>
+                <a:latin typeface="Calibri"/>
+              </a:defRPr>
+            </a:pPr>
+            <a:r>
+              <a:t>Vishruth Anand   ·   Vineeth Nareddy   ·   Rian Rahman   ·   James Reilly   ·   Jayanth Vennamreddy</a:t>
+            </a:r>
+          </a:p>
+          <a:p>
+            <a:pPr algn="ctr">
+              <a:defRPr sz="2000">
+                <a:solidFill>
+                  <a:srgbClr val="FFBBBB"/>
+                </a:solidFill>
+                <a:latin typeface="Calibri"/>
+              </a:defRPr>
+            </a:pPr>
+            <a:r>
+              <a:t>Georgia Institute of Technology  —  CSE 6242 Data and Visual Analytics  —  Team 46</a:t>
+            </a:r>
+          </a:p>
+        </p:txBody>
+      </p:sp>
+      <p:sp>
+        <p:nvSpPr>
+          <p:cNvPr id="7" name="Rounded Rectangle 6"/>
+          <p:cNvSpPr/>
+          <p:nvPr/>
+        </p:nvSpPr>
+        <p:spPr>
+          <a:xfrm>
+            <a:off x="457200" y="3474720"/>
+            <a:ext cx="13075920" cy="4206240"/>
+          </a:xfrm>
+          <a:prstGeom prst="roundRect">
+            <a:avLst>
+              <a:gd name="adj" fmla="val 2000"/>
+            </a:avLst>
+          </a:prstGeom>
           <a:solidFill>
-            <a:srgbClr val="C0392B"/>
+            <a:srgbClr val="F5F5F5"/>
           </a:solidFill>
-          <a:ln>
-            <a:noFill/>
+          <a:ln w="12700">
+            <a:solidFill>
+              <a:srgbClr val="E0E0E0"/>
+            </a:solidFill>
           </a:ln>
         </p:spPr>
         <p:style>
@@ -3474,135 +3352,20 @@
       </p:sp>
       <p:sp>
         <p:nvSpPr>
-          <p:cNvPr id="11" name="TextBox 10"/>
-          <p:cNvSpPr txBox="1"/>
-          <p:nvPr/>
-        </p:nvSpPr>
-        <p:spPr>
-          <a:xfrm>
-            <a:off x="548640" y="7315200"/>
-            <a:ext cx="12618720" cy="2560320"/>
-          </a:xfrm>
-          <a:prstGeom prst="rect">
-            <a:avLst/>
-          </a:prstGeom>
-          <a:noFill/>
-        </p:spPr>
-        <p:txBody>
-          <a:bodyPr wrap="square">
-            <a:spAutoFit/>
-          </a:bodyPr>
-          <a:lstStyle/>
-          <a:p>
-            <a:pPr algn="l">
-              <a:defRPr sz="2000" b="0">
-                <a:solidFill>
-                  <a:srgbClr val="444444"/>
-                </a:solidFill>
-              </a:defRPr>
-            </a:pPr>
-            <a:r>
-              <a:t>•  Incidents: 1,473 geocoded fire incidents from 2024 NFIRS PDR Light (FEMA ArcGIS FeatureServer), filtered to Atlanta, fire codes 100–199.</a:t>
-            </a:r>
-          </a:p>
-          <a:p>
-            <a:pPr>
-              <a:spcBef>
-                <a:spcPts val="800"/>
-              </a:spcBef>
-              <a:defRPr sz="2000" b="0">
-                <a:solidFill>
-                  <a:srgbClr val="444444"/>
-                </a:solidFill>
-              </a:defRPr>
-            </a:pPr>
-            <a:r>
-              <a:t>•  Weather: Open-Meteo daily archive for Atlanta — temperature, humidity, precipitation, wind speed. One row per day, merged citywide.</a:t>
-            </a:r>
-          </a:p>
-          <a:p>
-            <a:pPr>
-              <a:spcBef>
-                <a:spcPts val="800"/>
-              </a:spcBef>
-              <a:defRPr sz="2000" b="0">
-                <a:solidFill>
-                  <a:srgbClr val="444444"/>
-                </a:solidFill>
-              </a:defRPr>
-            </a:pPr>
-            <a:r>
-              <a:t>•  Grid: 1,176 cells at 1,000 m resolution over the Atlanta metro extent. 364 cells have at least one fire incident in the study period.</a:t>
-            </a:r>
-          </a:p>
-          <a:p>
-            <a:pPr>
-              <a:spcBef>
-                <a:spcPts val="800"/>
-              </a:spcBef>
-              <a:defRPr sz="2000" b="0">
-                <a:solidFill>
-                  <a:srgbClr val="444444"/>
-                </a:solidFill>
-              </a:defRPr>
-            </a:pPr>
-            <a:r>
-              <a:t>•  Model table: 132,860 cell-day rows with 18 features including weather, calendar, lags (1/3/7 day), and rolling sums (7/14 day).</a:t>
-            </a:r>
-          </a:p>
-        </p:txBody>
-      </p:sp>
-      <p:sp>
-        <p:nvSpPr>
-          <p:cNvPr id="12" name="TextBox 11"/>
-          <p:cNvSpPr txBox="1"/>
-          <p:nvPr/>
-        </p:nvSpPr>
-        <p:spPr>
-          <a:xfrm>
-            <a:off x="548640" y="10058400"/>
-            <a:ext cx="12618720" cy="502920"/>
-          </a:xfrm>
-          <a:prstGeom prst="rect">
-            <a:avLst/>
-          </a:prstGeom>
-          <a:noFill/>
-        </p:spPr>
-        <p:txBody>
-          <a:bodyPr wrap="square">
-            <a:spAutoFit/>
-          </a:bodyPr>
-          <a:lstStyle/>
-          <a:p>
-            <a:pPr algn="l">
-              <a:defRPr sz="2800" b="1">
-                <a:solidFill>
-                  <a:srgbClr val="C0392B"/>
-                </a:solidFill>
-              </a:defRPr>
-            </a:pPr>
-            <a:r>
-              <a:t>Methods</a:t>
-            </a:r>
-          </a:p>
-        </p:txBody>
-      </p:sp>
-      <p:sp>
-        <p:nvSpPr>
-          <p:cNvPr id="13" name="Rectangle 12"/>
+          <p:cNvPr id="8" name="Rectangle 7"/>
           <p:cNvSpPr/>
           <p:nvPr/>
         </p:nvSpPr>
         <p:spPr>
           <a:xfrm>
-            <a:off x="548640" y="10515600"/>
-            <a:ext cx="12618720" cy="36576"/>
+            <a:off x="777240" y="3794759"/>
+            <a:ext cx="109728" cy="457200"/>
           </a:xfrm>
           <a:prstGeom prst="rect">
             <a:avLst/>
           </a:prstGeom>
           <a:solidFill>
-            <a:srgbClr val="C0392B"/>
+            <a:srgbClr val="B71C1C"/>
           </a:solidFill>
           <a:ln>
             <a:noFill/>
@@ -3632,14 +3395,14 @@
       </p:sp>
       <p:sp>
         <p:nvSpPr>
-          <p:cNvPr id="14" name="TextBox 13"/>
+          <p:cNvPr id="9" name="TextBox 8"/>
           <p:cNvSpPr txBox="1"/>
           <p:nvPr/>
         </p:nvSpPr>
         <p:spPr>
           <a:xfrm>
-            <a:off x="548640" y="10607040"/>
-            <a:ext cx="12618720" cy="4206240"/>
+            <a:off x="978408" y="3794759"/>
+            <a:ext cx="12234672" cy="502920"/>
           </a:xfrm>
           <a:prstGeom prst="rect">
             <a:avLst/>
@@ -3652,82 +3415,612 @@
           </a:bodyPr>
           <a:lstStyle/>
           <a:p>
-            <a:pPr algn="l">
-              <a:defRPr sz="2000" b="0">
-                <a:solidFill>
-                  <a:srgbClr val="444444"/>
-                </a:solidFill>
+            <a:pPr>
+              <a:defRPr sz="3200" b="1">
+                <a:solidFill>
+                  <a:srgbClr val="B71C1C"/>
+                </a:solidFill>
+                <a:latin typeface="Calibri"/>
               </a:defRPr>
             </a:pPr>
             <a:r>
-              <a:t>•  Preprocessing: infer columns, standardize timestamps, project to UTM, assign grid cells, build full (cell × date) panel with lagged features.</a:t>
-            </a:r>
-          </a:p>
+              <a:t>INTRODUCTION</a:t>
+            </a:r>
+          </a:p>
+        </p:txBody>
+      </p:sp>
+      <p:sp>
+        <p:nvSpPr>
+          <p:cNvPr id="10" name="TextBox 9"/>
+          <p:cNvSpPr txBox="1"/>
+          <p:nvPr/>
+        </p:nvSpPr>
+        <p:spPr>
+          <a:xfrm>
+            <a:off x="777240" y="4389120"/>
+            <a:ext cx="12435840" cy="2926079"/>
+          </a:xfrm>
+          <a:prstGeom prst="rect">
+            <a:avLst/>
+          </a:prstGeom>
+          <a:noFill/>
+        </p:spPr>
+        <p:txBody>
+          <a:bodyPr wrap="square">
+            <a:spAutoFit/>
+          </a:bodyPr>
+          <a:lstStyle/>
           <a:p>
             <a:pPr>
+              <a:lnSpc>
+                <a:spcPts val="3000"/>
+              </a:lnSpc>
+              <a:defRPr sz="2200">
+                <a:solidFill>
+                  <a:srgbClr val="2D2D2D"/>
+                </a:solidFill>
+                <a:latin typeface="Calibri"/>
+              </a:defRPr>
+            </a:pPr>
+            <a:r>
+              <a:t>•   Fire departments make readiness decisions under uncertainty,</a:t>
+            </a:r>
+            <a:br/>
+            <a:r>
+              <a:t>yet incidents are not uniformly distributed across a city.</a:t>
+            </a:r>
+          </a:p>
+          <a:p>
+            <a:pPr>
+              <a:lnSpc>
+                <a:spcPts val="3000"/>
+              </a:lnSpc>
               <a:spcBef>
-                <a:spcPts val="800"/>
+                <a:spcPts val="1000"/>
               </a:spcBef>
-              <a:defRPr sz="2000" b="0">
-                <a:solidFill>
-                  <a:srgbClr val="444444"/>
-                </a:solidFill>
+              <a:defRPr sz="2200">
+                <a:solidFill>
+                  <a:srgbClr val="2D2D2D"/>
+                </a:solidFill>
+                <a:latin typeface="Calibri"/>
               </a:defRPr>
             </a:pPr>
             <a:r>
-              <a:t>•  Hotspot baseline: 2D Gaussian KDE over training cell centroids weighted by incident count. Captures static spatial density.</a:t>
+              <a:t>•   Current tools show what happened — not where risk is</a:t>
+            </a:r>
+            <a:br/>
+            <a:r>
+              <a:t>concentrated, how it changes, or why an area is flagged.</a:t>
             </a:r>
           </a:p>
           <a:p>
             <a:pPr>
+              <a:lnSpc>
+                <a:spcPts val="3000"/>
+              </a:lnSpc>
               <a:spcBef>
-                <a:spcPts val="800"/>
+                <a:spcPts val="1000"/>
               </a:spcBef>
-              <a:defRPr sz="2000" b="0">
-                <a:solidFill>
-                  <a:srgbClr val="444444"/>
-                </a:solidFill>
+              <a:defRPr sz="2200">
+                <a:solidFill>
+                  <a:srgbClr val="2D2D2D"/>
+                </a:solidFill>
+                <a:latin typeface="Calibri"/>
               </a:defRPr>
             </a:pPr>
             <a:r>
-              <a:t>•  ARIMA baseline: per-cell time-series model for up to 50 most active cells (min 5 nonzero days). Grid search over (p,d,q) by AIC.</a:t>
-            </a:r>
-          </a:p>
+              <a:t>•   We built an end-to-end system that forecasts next-day fire</a:t>
+            </a:r>
+            <a:br/>
+            <a:r>
+              <a:t>risk on a 1 km Atlanta grid and explains each prediction.</a:t>
+            </a:r>
+          </a:p>
+        </p:txBody>
+      </p:sp>
+      <p:sp>
+        <p:nvSpPr>
+          <p:cNvPr id="11" name="Rounded Rectangle 10"/>
+          <p:cNvSpPr/>
+          <p:nvPr/>
+        </p:nvSpPr>
+        <p:spPr>
+          <a:xfrm>
+            <a:off x="457200" y="8000999"/>
+            <a:ext cx="13075920" cy="4023360"/>
+          </a:xfrm>
+          <a:prstGeom prst="roundRect">
+            <a:avLst>
+              <a:gd name="adj" fmla="val 2000"/>
+            </a:avLst>
+          </a:prstGeom>
+          <a:solidFill>
+            <a:srgbClr val="F5F5F5"/>
+          </a:solidFill>
+          <a:ln w="12700">
+            <a:solidFill>
+              <a:srgbClr val="E0E0E0"/>
+            </a:solidFill>
+          </a:ln>
+        </p:spPr>
+        <p:style>
+          <a:lnRef idx="1">
+            <a:schemeClr val="accent1"/>
+          </a:lnRef>
+          <a:fillRef idx="3">
+            <a:schemeClr val="accent1"/>
+          </a:fillRef>
+          <a:effectRef idx="2">
+            <a:schemeClr val="accent1"/>
+          </a:effectRef>
+          <a:fontRef idx="minor">
+            <a:schemeClr val="lt1"/>
+          </a:fontRef>
+        </p:style>
+        <p:txBody>
+          <a:bodyPr rtlCol="0" anchor="ctr"/>
+          <a:lstStyle/>
+          <a:p>
+            <a:pPr algn="ctr"/>
+          </a:p>
+        </p:txBody>
+      </p:sp>
+      <p:sp>
+        <p:nvSpPr>
+          <p:cNvPr id="12" name="Rectangle 11"/>
+          <p:cNvSpPr/>
+          <p:nvPr/>
+        </p:nvSpPr>
+        <p:spPr>
+          <a:xfrm>
+            <a:off x="777240" y="8321039"/>
+            <a:ext cx="109728" cy="457200"/>
+          </a:xfrm>
+          <a:prstGeom prst="rect">
+            <a:avLst/>
+          </a:prstGeom>
+          <a:solidFill>
+            <a:srgbClr val="B71C1C"/>
+          </a:solidFill>
+          <a:ln>
+            <a:noFill/>
+          </a:ln>
+        </p:spPr>
+        <p:style>
+          <a:lnRef idx="1">
+            <a:schemeClr val="accent1"/>
+          </a:lnRef>
+          <a:fillRef idx="3">
+            <a:schemeClr val="accent1"/>
+          </a:fillRef>
+          <a:effectRef idx="2">
+            <a:schemeClr val="accent1"/>
+          </a:effectRef>
+          <a:fontRef idx="minor">
+            <a:schemeClr val="lt1"/>
+          </a:fontRef>
+        </p:style>
+        <p:txBody>
+          <a:bodyPr rtlCol="0" anchor="ctr"/>
+          <a:lstStyle/>
+          <a:p>
+            <a:pPr algn="ctr"/>
+          </a:p>
+        </p:txBody>
+      </p:sp>
+      <p:sp>
+        <p:nvSpPr>
+          <p:cNvPr id="13" name="TextBox 12"/>
+          <p:cNvSpPr txBox="1"/>
+          <p:nvPr/>
+        </p:nvSpPr>
+        <p:spPr>
+          <a:xfrm>
+            <a:off x="978408" y="8321039"/>
+            <a:ext cx="12234672" cy="502920"/>
+          </a:xfrm>
+          <a:prstGeom prst="rect">
+            <a:avLst/>
+          </a:prstGeom>
+          <a:noFill/>
+        </p:spPr>
+        <p:txBody>
+          <a:bodyPr wrap="square">
+            <a:spAutoFit/>
+          </a:bodyPr>
+          <a:lstStyle/>
           <a:p>
             <a:pPr>
+              <a:defRPr sz="3200" b="1">
+                <a:solidFill>
+                  <a:srgbClr val="B71C1C"/>
+                </a:solidFill>
+                <a:latin typeface="Calibri"/>
+              </a:defRPr>
+            </a:pPr>
+            <a:r>
+              <a:t>DATA</a:t>
+            </a:r>
+          </a:p>
+        </p:txBody>
+      </p:sp>
+      <p:sp>
+        <p:nvSpPr>
+          <p:cNvPr id="14" name="TextBox 13"/>
+          <p:cNvSpPr txBox="1"/>
+          <p:nvPr/>
+        </p:nvSpPr>
+        <p:spPr>
+          <a:xfrm>
+            <a:off x="777240" y="8915399"/>
+            <a:ext cx="12435840" cy="2743200"/>
+          </a:xfrm>
+          <a:prstGeom prst="rect">
+            <a:avLst/>
+          </a:prstGeom>
+          <a:noFill/>
+        </p:spPr>
+        <p:txBody>
+          <a:bodyPr wrap="square">
+            <a:spAutoFit/>
+          </a:bodyPr>
+          <a:lstStyle/>
+          <a:p>
+            <a:pPr>
+              <a:lnSpc>
+                <a:spcPts val="3000"/>
+              </a:lnSpc>
+              <a:defRPr sz="2200">
+                <a:solidFill>
+                  <a:srgbClr val="2D2D2D"/>
+                </a:solidFill>
+                <a:latin typeface="Calibri"/>
+              </a:defRPr>
+            </a:pPr>
+            <a:r>
+              <a:t>•   1,473 geocoded fire incidents from 2024 NFIRS PDR Light</a:t>
+            </a:r>
+            <a:br/>
+            <a:r>
+              <a:t>(Atlanta, fire codes 100–199, deduplicated).</a:t>
+            </a:r>
+          </a:p>
+          <a:p>
+            <a:pPr>
+              <a:lnSpc>
+                <a:spcPts val="3000"/>
+              </a:lnSpc>
               <a:spcBef>
-                <a:spcPts val="800"/>
+                <a:spcPts val="1000"/>
               </a:spcBef>
-              <a:defRPr sz="2000" b="0">
-                <a:solidFill>
-                  <a:srgbClr val="444444"/>
-                </a:solidFill>
+              <a:defRPr sz="2200">
+                <a:solidFill>
+                  <a:srgbClr val="2D2D2D"/>
+                </a:solidFill>
+                <a:latin typeface="Calibri"/>
               </a:defRPr>
             </a:pPr>
             <a:r>
-              <a:t>•  Random Forest: 300 trees, max depth 15, balanced class weights. Uses all 14 features including encoded grid_id for cell-level effects.</a:t>
+              <a:t>•   Daily weather from Open-Meteo: temperature, humidity,</a:t>
+            </a:r>
+            <a:br/>
+            <a:r>
+              <a:t>precipitation, wind speed (citywide, one row per day).</a:t>
             </a:r>
           </a:p>
           <a:p>
             <a:pPr>
+              <a:lnSpc>
+                <a:spcPts val="3000"/>
+              </a:lnSpc>
               <a:spcBef>
-                <a:spcPts val="800"/>
+                <a:spcPts val="1000"/>
               </a:spcBef>
-              <a:defRPr sz="2000" b="0">
-                <a:solidFill>
-                  <a:srgbClr val="444444"/>
-                </a:solidFill>
+              <a:defRPr sz="2200">
+                <a:solidFill>
+                  <a:srgbClr val="2D2D2D"/>
+                </a:solidFill>
+                <a:latin typeface="Calibri"/>
               </a:defRPr>
             </a:pPr>
             <a:r>
-              <a:t>•  Temporal split: first 80% of dates for training (Jan–Oct), last 20% for testing (Oct 19–Dec 30). No row shuffling.</a:t>
-            </a:r>
+              <a:t>•   1,176 grid cells at 1 km resolution; 132,860 cell-day rows</a:t>
+            </a:r>
+            <a:br/>
+            <a:r>
+              <a:t>with 18 features (weather, calendar, lags, rolling sums).</a:t>
+            </a:r>
+          </a:p>
+        </p:txBody>
+      </p:sp>
+      <p:sp>
+        <p:nvSpPr>
+          <p:cNvPr id="15" name="Rounded Rectangle 14"/>
+          <p:cNvSpPr/>
+          <p:nvPr/>
+        </p:nvSpPr>
+        <p:spPr>
+          <a:xfrm>
+            <a:off x="457200" y="12344399"/>
+            <a:ext cx="13075920" cy="6583680"/>
+          </a:xfrm>
+          <a:prstGeom prst="roundRect">
+            <a:avLst>
+              <a:gd name="adj" fmla="val 2000"/>
+            </a:avLst>
+          </a:prstGeom>
+          <a:solidFill>
+            <a:srgbClr val="F5F5F5"/>
+          </a:solidFill>
+          <a:ln w="12700">
+            <a:solidFill>
+              <a:srgbClr val="E0E0E0"/>
+            </a:solidFill>
+          </a:ln>
+        </p:spPr>
+        <p:style>
+          <a:lnRef idx="1">
+            <a:schemeClr val="accent1"/>
+          </a:lnRef>
+          <a:fillRef idx="3">
+            <a:schemeClr val="accent1"/>
+          </a:fillRef>
+          <a:effectRef idx="2">
+            <a:schemeClr val="accent1"/>
+          </a:effectRef>
+          <a:fontRef idx="minor">
+            <a:schemeClr val="lt1"/>
+          </a:fontRef>
+        </p:style>
+        <p:txBody>
+          <a:bodyPr rtlCol="0" anchor="ctr"/>
+          <a:lstStyle/>
+          <a:p>
+            <a:pPr algn="ctr"/>
+          </a:p>
+        </p:txBody>
+      </p:sp>
+      <p:sp>
+        <p:nvSpPr>
+          <p:cNvPr id="16" name="Rectangle 15"/>
+          <p:cNvSpPr/>
+          <p:nvPr/>
+        </p:nvSpPr>
+        <p:spPr>
+          <a:xfrm>
+            <a:off x="777240" y="12664439"/>
+            <a:ext cx="109728" cy="457200"/>
+          </a:xfrm>
+          <a:prstGeom prst="rect">
+            <a:avLst/>
+          </a:prstGeom>
+          <a:solidFill>
+            <a:srgbClr val="B71C1C"/>
+          </a:solidFill>
+          <a:ln>
+            <a:noFill/>
+          </a:ln>
+        </p:spPr>
+        <p:style>
+          <a:lnRef idx="1">
+            <a:schemeClr val="accent1"/>
+          </a:lnRef>
+          <a:fillRef idx="3">
+            <a:schemeClr val="accent1"/>
+          </a:fillRef>
+          <a:effectRef idx="2">
+            <a:schemeClr val="accent1"/>
+          </a:effectRef>
+          <a:fontRef idx="minor">
+            <a:schemeClr val="lt1"/>
+          </a:fontRef>
+        </p:style>
+        <p:txBody>
+          <a:bodyPr rtlCol="0" anchor="ctr"/>
+          <a:lstStyle/>
+          <a:p>
+            <a:pPr algn="ctr"/>
+          </a:p>
+        </p:txBody>
+      </p:sp>
+      <p:sp>
+        <p:nvSpPr>
+          <p:cNvPr id="17" name="TextBox 16"/>
+          <p:cNvSpPr txBox="1"/>
+          <p:nvPr/>
+        </p:nvSpPr>
+        <p:spPr>
+          <a:xfrm>
+            <a:off x="978408" y="12664439"/>
+            <a:ext cx="12234672" cy="502920"/>
+          </a:xfrm>
+          <a:prstGeom prst="rect">
+            <a:avLst/>
+          </a:prstGeom>
+          <a:noFill/>
+        </p:spPr>
+        <p:txBody>
+          <a:bodyPr wrap="square">
+            <a:spAutoFit/>
+          </a:bodyPr>
+          <a:lstStyle/>
+          <a:p>
+            <a:pPr>
+              <a:defRPr sz="3200" b="1">
+                <a:solidFill>
+                  <a:srgbClr val="B71C1C"/>
+                </a:solidFill>
+                <a:latin typeface="Calibri"/>
+              </a:defRPr>
+            </a:pPr>
+            <a:r>
+              <a:t>METHODS</a:t>
+            </a:r>
+          </a:p>
+        </p:txBody>
+      </p:sp>
+      <p:sp>
+        <p:nvSpPr>
+          <p:cNvPr id="18" name="TextBox 17"/>
+          <p:cNvSpPr txBox="1"/>
+          <p:nvPr/>
+        </p:nvSpPr>
+        <p:spPr>
+          <a:xfrm>
+            <a:off x="777240" y="13258799"/>
+            <a:ext cx="12435840" cy="5303520"/>
+          </a:xfrm>
+          <a:prstGeom prst="rect">
+            <a:avLst/>
+          </a:prstGeom>
+          <a:noFill/>
+        </p:spPr>
+        <p:txBody>
+          <a:bodyPr wrap="square">
+            <a:spAutoFit/>
+          </a:bodyPr>
+          <a:lstStyle/>
+          <a:p>
+            <a:pPr>
+              <a:lnSpc>
+                <a:spcPts val="3000"/>
+              </a:lnSpc>
+              <a:defRPr sz="2200">
+                <a:solidFill>
+                  <a:srgbClr val="2D2D2D"/>
+                </a:solidFill>
+                <a:latin typeface="Calibri"/>
+              </a:defRPr>
+            </a:pPr>
+            <a:r>
+              <a:t>•   Hotspot baseline: Gaussian KDE over training centroids</a:t>
+            </a:r>
+            <a:br/>
+            <a:r>
+              <a:t>weighted by count. Captures static spatial density only.</a:t>
+            </a:r>
+          </a:p>
+          <a:p>
+            <a:pPr>
+              <a:lnSpc>
+                <a:spcPts val="3000"/>
+              </a:lnSpc>
+              <a:spcBef>
+                <a:spcPts val="1000"/>
+              </a:spcBef>
+              <a:defRPr sz="2200">
+                <a:solidFill>
+                  <a:srgbClr val="2D2D2D"/>
+                </a:solidFill>
+                <a:latin typeface="Calibri"/>
+              </a:defRPr>
+            </a:pPr>
+            <a:r>
+              <a:t>•   ARIMA baseline: per-cell time-series for top 50 cells.</a:t>
+            </a:r>
+            <a:br/>
+            <a:r>
+              <a:t>Grid search (p,d,q) by AIC; fallback for sparse cells.</a:t>
+            </a:r>
+          </a:p>
+          <a:p>
+            <a:pPr>
+              <a:lnSpc>
+                <a:spcPts val="3000"/>
+              </a:lnSpc>
+              <a:spcBef>
+                <a:spcPts val="1000"/>
+              </a:spcBef>
+              <a:defRPr sz="2200">
+                <a:solidFill>
+                  <a:srgbClr val="2D2D2D"/>
+                </a:solidFill>
+                <a:latin typeface="Calibri"/>
+              </a:defRPr>
+            </a:pPr>
+            <a:r>
+              <a:t>•   Random Forest (main model): 300 trees, max depth 15,</a:t>
+            </a:r>
+            <a:br/>
+            <a:r>
+              <a:t>balanced weights. Uses all 14 features + encoded grid_id.</a:t>
+            </a:r>
+          </a:p>
+          <a:p>
+            <a:pPr>
+              <a:lnSpc>
+                <a:spcPts val="3000"/>
+              </a:lnSpc>
+              <a:spcBef>
+                <a:spcPts val="1000"/>
+              </a:spcBef>
+              <a:defRPr sz="2200">
+                <a:solidFill>
+                  <a:srgbClr val="2D2D2D"/>
+                </a:solidFill>
+                <a:latin typeface="Calibri"/>
+              </a:defRPr>
+            </a:pPr>
+            <a:r>
+              <a:t>•   Temporal 80/20 split: train Jan–Oct 18, test Oct 19–Dec 30.</a:t>
+            </a:r>
+            <a:br/>
+            <a:r>
+              <a:t>No row shuffling to prevent future-data leakage.</a:t>
+            </a:r>
+          </a:p>
+        </p:txBody>
+      </p:sp>
+      <p:sp>
+        <p:nvSpPr>
+          <p:cNvPr id="19" name="Rounded Rectangle 18"/>
+          <p:cNvSpPr/>
+          <p:nvPr/>
+        </p:nvSpPr>
+        <p:spPr>
+          <a:xfrm>
+            <a:off x="457200" y="19248120"/>
+            <a:ext cx="13075920" cy="8686800"/>
+          </a:xfrm>
+          <a:prstGeom prst="roundRect">
+            <a:avLst>
+              <a:gd name="adj" fmla="val 2000"/>
+            </a:avLst>
+          </a:prstGeom>
+          <a:solidFill>
+            <a:srgbClr val="F5F5F5"/>
+          </a:solidFill>
+          <a:ln w="12700">
+            <a:solidFill>
+              <a:srgbClr val="E0E0E0"/>
+            </a:solidFill>
+          </a:ln>
+        </p:spPr>
+        <p:style>
+          <a:lnRef idx="1">
+            <a:schemeClr val="accent1"/>
+          </a:lnRef>
+          <a:fillRef idx="3">
+            <a:schemeClr val="accent1"/>
+          </a:fillRef>
+          <a:effectRef idx="2">
+            <a:schemeClr val="accent1"/>
+          </a:effectRef>
+          <a:fontRef idx="minor">
+            <a:schemeClr val="lt1"/>
+          </a:fontRef>
+        </p:style>
+        <p:txBody>
+          <a:bodyPr rtlCol="0" anchor="ctr"/>
+          <a:lstStyle/>
+          <a:p>
+            <a:pPr algn="ctr"/>
           </a:p>
         </p:txBody>
       </p:sp>
       <p:pic>
         <p:nvPicPr>
-          <p:cNvPr id="15" name="Picture 14" descr="risk_map_aggregate.png"/>
+          <p:cNvPr id="20" name="Picture 19" descr="risk_map_aggregate.png"/>
           <p:cNvPicPr>
             <a:picLocks noChangeAspect="1"/>
           </p:cNvPicPr>
@@ -3741,8 +4034,8 @@
         </p:blipFill>
         <p:spPr>
           <a:xfrm>
-            <a:off x="1920240" y="14721840"/>
-            <a:ext cx="9601200" cy="10127762"/>
+            <a:off x="3337560" y="19522440"/>
+            <a:ext cx="7315200" cy="7716390"/>
           </a:xfrm>
           <a:prstGeom prst="rect">
             <a:avLst/>
@@ -3751,14 +4044,14 @@
       </p:pic>
       <p:sp>
         <p:nvSpPr>
-          <p:cNvPr id="16" name="TextBox 15"/>
+          <p:cNvPr id="21" name="TextBox 20"/>
           <p:cNvSpPr txBox="1"/>
           <p:nvPr/>
         </p:nvSpPr>
         <p:spPr>
           <a:xfrm>
-            <a:off x="548640" y="24871680"/>
-            <a:ext cx="12618720" cy="457200"/>
+            <a:off x="777240" y="27157680"/>
+            <a:ext cx="12435840" cy="365760"/>
           </a:xfrm>
           <a:prstGeom prst="rect">
             <a:avLst/>
@@ -3772,72 +4065,42 @@
           <a:lstStyle/>
           <a:p>
             <a:pPr algn="ctr">
-              <a:defRPr sz="1800" b="0">
-                <a:solidFill>
-                  <a:srgbClr val="444444"/>
-                </a:solidFill>
+              <a:defRPr sz="1600" i="1">
+                <a:solidFill>
+                  <a:srgbClr val="666666"/>
+                </a:solidFill>
+                <a:latin typeface="Calibri"/>
               </a:defRPr>
             </a:pPr>
             <a:r>
-              <a:t>Figure 1: Aggregate RF risk heatmap across all test dates (Atlanta 1 km grid)</a:t>
-            </a:r>
-          </a:p>
-        </p:txBody>
-      </p:sp>
-      <p:sp>
-        <p:nvSpPr>
-          <p:cNvPr id="17" name="TextBox 16"/>
-          <p:cNvSpPr txBox="1"/>
-          <p:nvPr/>
-        </p:nvSpPr>
-        <p:spPr>
-          <a:xfrm>
-            <a:off x="548640" y="25694640"/>
-            <a:ext cx="12618720" cy="502920"/>
-          </a:xfrm>
-          <a:prstGeom prst="rect">
-            <a:avLst/>
-          </a:prstGeom>
-          <a:noFill/>
-        </p:spPr>
-        <p:txBody>
-          <a:bodyPr wrap="square">
-            <a:spAutoFit/>
-          </a:bodyPr>
-          <a:lstStyle/>
-          <a:p>
-            <a:pPr algn="l">
-              <a:defRPr sz="2800" b="1">
-                <a:solidFill>
-                  <a:srgbClr val="C0392B"/>
-                </a:solidFill>
-              </a:defRPr>
-            </a:pPr>
-            <a:r>
-              <a:t>Interactive Dashboard</a:t>
-            </a:r>
-          </a:p>
-        </p:txBody>
-      </p:sp>
-      <p:sp>
-        <p:nvSpPr>
-          <p:cNvPr id="18" name="Rectangle 17"/>
+              <a:t>Fig. 1: Aggregate RF risk across all test dates (Atlanta 1 km grid)</a:t>
+            </a:r>
+          </a:p>
+        </p:txBody>
+      </p:sp>
+      <p:sp>
+        <p:nvSpPr>
+          <p:cNvPr id="22" name="Rounded Rectangle 21"/>
           <p:cNvSpPr/>
           <p:nvPr/>
         </p:nvSpPr>
         <p:spPr>
           <a:xfrm>
-            <a:off x="548640" y="26151840"/>
-            <a:ext cx="12618720" cy="36576"/>
-          </a:xfrm>
-          <a:prstGeom prst="rect">
-            <a:avLst/>
+            <a:off x="457200" y="28254960"/>
+            <a:ext cx="13075920" cy="7863839"/>
+          </a:xfrm>
+          <a:prstGeom prst="roundRect">
+            <a:avLst>
+              <a:gd name="adj" fmla="val 2000"/>
+            </a:avLst>
           </a:prstGeom>
           <a:solidFill>
-            <a:srgbClr val="C0392B"/>
+            <a:srgbClr val="F5F5F5"/>
           </a:solidFill>
-          <a:ln>
-            <a:noFill/>
+          <a:ln w="12700">
+            <a:solidFill>
+              <a:srgbClr val="E0E0E0"/>
+            </a:solidFill>
           </a:ln>
         </p:spPr>
         <p:style>
@@ -3864,14 +4127,57 @@
       </p:sp>
       <p:sp>
         <p:nvSpPr>
-          <p:cNvPr id="19" name="TextBox 18"/>
+          <p:cNvPr id="23" name="Rectangle 22"/>
+          <p:cNvSpPr/>
+          <p:nvPr/>
+        </p:nvSpPr>
+        <p:spPr>
+          <a:xfrm>
+            <a:off x="777240" y="28575000"/>
+            <a:ext cx="109728" cy="457200"/>
+          </a:xfrm>
+          <a:prstGeom prst="rect">
+            <a:avLst/>
+          </a:prstGeom>
+          <a:solidFill>
+            <a:srgbClr val="B71C1C"/>
+          </a:solidFill>
+          <a:ln>
+            <a:noFill/>
+          </a:ln>
+        </p:spPr>
+        <p:style>
+          <a:lnRef idx="1">
+            <a:schemeClr val="accent1"/>
+          </a:lnRef>
+          <a:fillRef idx="3">
+            <a:schemeClr val="accent1"/>
+          </a:fillRef>
+          <a:effectRef idx="2">
+            <a:schemeClr val="accent1"/>
+          </a:effectRef>
+          <a:fontRef idx="minor">
+            <a:schemeClr val="lt1"/>
+          </a:fontRef>
+        </p:style>
+        <p:txBody>
+          <a:bodyPr rtlCol="0" anchor="ctr"/>
+          <a:lstStyle/>
+          <a:p>
+            <a:pPr algn="ctr"/>
+          </a:p>
+        </p:txBody>
+      </p:sp>
+      <p:sp>
+        <p:nvSpPr>
+          <p:cNvPr id="24" name="TextBox 23"/>
           <p:cNvSpPr txBox="1"/>
           <p:nvPr/>
         </p:nvSpPr>
         <p:spPr>
           <a:xfrm>
-            <a:off x="548640" y="26243280"/>
-            <a:ext cx="12618720" cy="2560320"/>
+            <a:off x="978408" y="28575000"/>
+            <a:ext cx="12234672" cy="502920"/>
           </a:xfrm>
           <a:prstGeom prst="rect">
             <a:avLst/>
@@ -3884,67 +4190,89 @@
           </a:bodyPr>
           <a:lstStyle/>
           <a:p>
-            <a:pPr algn="l">
-              <a:defRPr sz="2000" b="0">
-                <a:solidFill>
-                  <a:srgbClr val="444444"/>
-                </a:solidFill>
+            <a:pPr>
+              <a:defRPr sz="3200" b="1">
+                <a:solidFill>
+                  <a:srgbClr val="B71C1C"/>
+                </a:solidFill>
+                <a:latin typeface="Calibri"/>
               </a:defRPr>
             </a:pPr>
             <a:r>
-              <a:t>•  Leaflet basemap + D3 analytical views in a single-page web app.</a:t>
-            </a:r>
-          </a:p>
+              <a:t>INTERACTIVE DASHBOARD</a:t>
+            </a:r>
+          </a:p>
+        </p:txBody>
+      </p:sp>
+      <p:sp>
+        <p:nvSpPr>
+          <p:cNvPr id="25" name="TextBox 24"/>
+          <p:cNvSpPr txBox="1"/>
+          <p:nvPr/>
+        </p:nvSpPr>
+        <p:spPr>
+          <a:xfrm>
+            <a:off x="777240" y="29169360"/>
+            <a:ext cx="12435840" cy="2743200"/>
+          </a:xfrm>
+          <a:prstGeom prst="rect">
+            <a:avLst/>
+          </a:prstGeom>
+          <a:noFill/>
+        </p:spPr>
+        <p:txBody>
+          <a:bodyPr wrap="square">
+            <a:spAutoFit/>
+          </a:bodyPr>
+          <a:lstStyle/>
           <a:p>
             <a:pPr>
+              <a:lnSpc>
+                <a:spcPts val="3000"/>
+              </a:lnSpc>
+              <a:defRPr sz="2200">
+                <a:solidFill>
+                  <a:srgbClr val="2D2D2D"/>
+                </a:solidFill>
+                <a:latin typeface="Calibri"/>
+              </a:defRPr>
+            </a:pPr>
+            <a:r>
+              <a:t>•   Leaflet map + D3 analytics. Metric selector, date slider</a:t>
+            </a:r>
+            <a:br/>
+            <a:r>
+              <a:t>with play/pause, linked histogram and time-series views.</a:t>
+            </a:r>
+          </a:p>
+          <a:p>
+            <a:pPr>
+              <a:lnSpc>
+                <a:spcPts val="3000"/>
+              </a:lnSpc>
               <a:spcBef>
-                <a:spcPts val="800"/>
+                <a:spcPts val="1000"/>
               </a:spcBef>
-              <a:defRPr sz="2000" b="0">
-                <a:solidFill>
-                  <a:srgbClr val="444444"/>
-                </a:solidFill>
+              <a:defRPr sz="2200">
+                <a:solidFill>
+                  <a:srgbClr val="2D2D2D"/>
+                </a:solidFill>
+                <a:latin typeface="Calibri"/>
               </a:defRPr>
             </a:pPr>
             <a:r>
-              <a:t>•  Metric dropdown: RF probability, hotspot, ARIMA, incident count, target.</a:t>
-            </a:r>
-          </a:p>
-          <a:p>
-            <a:pPr>
-              <a:spcBef>
-                <a:spcPts val="800"/>
-              </a:spcBef>
-              <a:defRPr sz="2000" b="0">
-                <a:solidFill>
-                  <a:srgbClr val="444444"/>
-                </a:solidFill>
-              </a:defRPr>
-            </a:pPr>
-            <a:r>
-              <a:t>•  Date slider with play/pause animates through 73 test dates; all views update together.</a:t>
-            </a:r>
-          </a:p>
-          <a:p>
-            <a:pPr>
-              <a:spcBef>
-                <a:spcPts val="800"/>
-              </a:spcBef>
-              <a:defRPr sz="2000" b="0">
-                <a:solidFill>
-                  <a:srgbClr val="444444"/>
-                </a:solidFill>
-              </a:defRPr>
-            </a:pPr>
-            <a:r>
-              <a:t>•  Click a cell to see: score histogram, probability time series, feature snapshot, and SHAP explanation with driver bar chart.</a:t>
+              <a:t>•   Click any cell: feature snapshot, SHAP explanation panel</a:t>
+            </a:r>
+            <a:br/>
+            <a:r>
+              <a:t>with driver bar chart and narrative sentence.</a:t>
             </a:r>
           </a:p>
         </p:txBody>
       </p:sp>
       <p:pic>
         <p:nvPicPr>
-          <p:cNvPr id="20" name="Picture 19" descr="app_full.png"/>
+          <p:cNvPr id="26" name="Picture 25" descr="app_full.png"/>
           <p:cNvPicPr>
             <a:picLocks noChangeAspect="1"/>
           </p:cNvPicPr>
@@ -3958,8 +4286,8 @@
         </p:blipFill>
         <p:spPr>
           <a:xfrm>
-            <a:off x="1005840" y="28895040"/>
-            <a:ext cx="11704320" cy="7524206"/>
+            <a:off x="1280160" y="32095440"/>
+            <a:ext cx="11430000" cy="7347857"/>
           </a:xfrm>
           <a:prstGeom prst="rect">
             <a:avLst/>
@@ -3968,14 +4296,14 @@
       </p:pic>
       <p:sp>
         <p:nvSpPr>
-          <p:cNvPr id="21" name="TextBox 20"/>
+          <p:cNvPr id="27" name="TextBox 26"/>
           <p:cNvSpPr txBox="1"/>
           <p:nvPr/>
         </p:nvSpPr>
         <p:spPr>
           <a:xfrm>
-            <a:off x="548640" y="35661600"/>
-            <a:ext cx="12618720" cy="457200"/>
+            <a:off x="777240" y="39227760"/>
+            <a:ext cx="12435840" cy="365760"/>
           </a:xfrm>
           <a:prstGeom prst="rect">
             <a:avLst/>
@@ -3989,72 +4317,42 @@
           <a:lstStyle/>
           <a:p>
             <a:pPr algn="ctr">
-              <a:defRPr sz="1800" b="0">
-                <a:solidFill>
-                  <a:srgbClr val="444444"/>
-                </a:solidFill>
+              <a:defRPr sz="1600" i="1">
+                <a:solidFill>
+                  <a:srgbClr val="666666"/>
+                </a:solidFill>
+                <a:latin typeface="Calibri"/>
               </a:defRPr>
             </a:pPr>
             <a:r>
-              <a:t>Figure 2: Dashboard with choropleth map, time slider, histogram, and SHAP explanation panel</a:t>
-            </a:r>
-          </a:p>
-        </p:txBody>
-      </p:sp>
-      <p:sp>
-        <p:nvSpPr>
-          <p:cNvPr id="22" name="TextBox 21"/>
-          <p:cNvSpPr txBox="1"/>
-          <p:nvPr/>
-        </p:nvSpPr>
-        <p:spPr>
-          <a:xfrm>
-            <a:off x="14173200" y="3291840"/>
-            <a:ext cx="12618720" cy="502920"/>
-          </a:xfrm>
-          <a:prstGeom prst="rect">
-            <a:avLst/>
-          </a:prstGeom>
-          <a:noFill/>
-        </p:spPr>
-        <p:txBody>
-          <a:bodyPr wrap="square">
-            <a:spAutoFit/>
-          </a:bodyPr>
-          <a:lstStyle/>
-          <a:p>
-            <a:pPr algn="l">
-              <a:defRPr sz="2800" b="1">
-                <a:solidFill>
-                  <a:srgbClr val="C0392B"/>
-                </a:solidFill>
-              </a:defRPr>
-            </a:pPr>
-            <a:r>
-              <a:t>Results</a:t>
-            </a:r>
-          </a:p>
-        </p:txBody>
-      </p:sp>
-      <p:sp>
-        <p:nvSpPr>
-          <p:cNvPr id="23" name="Rectangle 22"/>
+              <a:t>Fig. 2: Dashboard with choropleth, time control, and explanation panel</a:t>
+            </a:r>
+          </a:p>
+        </p:txBody>
+      </p:sp>
+      <p:sp>
+        <p:nvSpPr>
+          <p:cNvPr id="28" name="Rounded Rectangle 27"/>
           <p:cNvSpPr/>
           <p:nvPr/>
         </p:nvSpPr>
         <p:spPr>
           <a:xfrm>
-            <a:off x="14173200" y="3749040"/>
-            <a:ext cx="12618720" cy="36576"/>
-          </a:xfrm>
-          <a:prstGeom prst="rect">
-            <a:avLst/>
+            <a:off x="13898880" y="3474720"/>
+            <a:ext cx="13075920" cy="4206240"/>
+          </a:xfrm>
+          <a:prstGeom prst="roundRect">
+            <a:avLst>
+              <a:gd name="adj" fmla="val 2000"/>
+            </a:avLst>
           </a:prstGeom>
           <a:solidFill>
-            <a:srgbClr val="C0392B"/>
+            <a:srgbClr val="F5F5F5"/>
           </a:solidFill>
-          <a:ln>
-            <a:noFill/>
+          <a:ln w="12700">
+            <a:solidFill>
+              <a:srgbClr val="E0E0E0"/>
+            </a:solidFill>
           </a:ln>
         </p:spPr>
         <p:style>
@@ -4081,14 +4379,57 @@
       </p:sp>
       <p:sp>
         <p:nvSpPr>
-          <p:cNvPr id="24" name="TextBox 23"/>
+          <p:cNvPr id="29" name="Rectangle 28"/>
+          <p:cNvSpPr/>
+          <p:nvPr/>
+        </p:nvSpPr>
+        <p:spPr>
+          <a:xfrm>
+            <a:off x="14218920" y="3794759"/>
+            <a:ext cx="109728" cy="457200"/>
+          </a:xfrm>
+          <a:prstGeom prst="rect">
+            <a:avLst/>
+          </a:prstGeom>
+          <a:solidFill>
+            <a:srgbClr val="B71C1C"/>
+          </a:solidFill>
+          <a:ln>
+            <a:noFill/>
+          </a:ln>
+        </p:spPr>
+        <p:style>
+          <a:lnRef idx="1">
+            <a:schemeClr val="accent1"/>
+          </a:lnRef>
+          <a:fillRef idx="3">
+            <a:schemeClr val="accent1"/>
+          </a:fillRef>
+          <a:effectRef idx="2">
+            <a:schemeClr val="accent1"/>
+          </a:effectRef>
+          <a:fontRef idx="minor">
+            <a:schemeClr val="lt1"/>
+          </a:fontRef>
+        </p:style>
+        <p:txBody>
+          <a:bodyPr rtlCol="0" anchor="ctr"/>
+          <a:lstStyle/>
+          <a:p>
+            <a:pPr algn="ctr"/>
+          </a:p>
+        </p:txBody>
+      </p:sp>
+      <p:sp>
+        <p:nvSpPr>
+          <p:cNvPr id="30" name="TextBox 29"/>
           <p:cNvSpPr txBox="1"/>
           <p:nvPr/>
         </p:nvSpPr>
         <p:spPr>
           <a:xfrm>
-            <a:off x="14173200" y="3840480"/>
-            <a:ext cx="12618720" cy="3840480"/>
+            <a:off x="14420088" y="3794759"/>
+            <a:ext cx="12234672" cy="502920"/>
           </a:xfrm>
           <a:prstGeom prst="rect">
             <a:avLst/>
@@ -4101,67 +4442,159 @@
           </a:bodyPr>
           <a:lstStyle/>
           <a:p>
-            <a:pPr algn="l">
-              <a:defRPr sz="2000" b="0">
-                <a:solidFill>
-                  <a:srgbClr val="444444"/>
-                </a:solidFill>
+            <a:pPr>
+              <a:defRPr sz="3200" b="1">
+                <a:solidFill>
+                  <a:srgbClr val="B71C1C"/>
+                </a:solidFill>
+                <a:latin typeface="Calibri"/>
               </a:defRPr>
             </a:pPr>
             <a:r>
-              <a:t>•  Test set: 26,572 cell-date observations, 138 positive (0.52%). Extreme imbalance makes accuracy misleading (all models &gt; 98%).</a:t>
-            </a:r>
-          </a:p>
+              <a:t>RESULTS</a:t>
+            </a:r>
+          </a:p>
+        </p:txBody>
+      </p:sp>
+      <p:sp>
+        <p:nvSpPr>
+          <p:cNvPr id="31" name="TextBox 30"/>
+          <p:cNvSpPr txBox="1"/>
+          <p:nvPr/>
+        </p:nvSpPr>
+        <p:spPr>
+          <a:xfrm>
+            <a:off x="14218920" y="4389120"/>
+            <a:ext cx="12435840" cy="3291840"/>
+          </a:xfrm>
+          <a:prstGeom prst="rect">
+            <a:avLst/>
+          </a:prstGeom>
+          <a:noFill/>
+        </p:spPr>
+        <p:txBody>
+          <a:bodyPr wrap="square">
+            <a:spAutoFit/>
+          </a:bodyPr>
+          <a:lstStyle/>
           <a:p>
             <a:pPr>
+              <a:lnSpc>
+                <a:spcPts val="3000"/>
+              </a:lnSpc>
+              <a:defRPr sz="2200">
+                <a:solidFill>
+                  <a:srgbClr val="2D2D2D"/>
+                </a:solidFill>
+                <a:latin typeface="Calibri"/>
+              </a:defRPr>
+            </a:pPr>
+            <a:r>
+              <a:t>•   Test set: 26,572 cell-days, only 138 positive (0.52%).</a:t>
+            </a:r>
+            <a:br/>
+            <a:r>
+              <a:t>Extreme imbalance makes accuracy misleading (all &gt; 98%).</a:t>
+            </a:r>
+          </a:p>
+          <a:p>
+            <a:pPr>
+              <a:lnSpc>
+                <a:spcPts val="3000"/>
+              </a:lnSpc>
               <a:spcBef>
-                <a:spcPts val="800"/>
+                <a:spcPts val="1000"/>
               </a:spcBef>
-              <a:defRPr sz="2000" b="0">
-                <a:solidFill>
-                  <a:srgbClr val="444444"/>
-                </a:solidFill>
+              <a:defRPr sz="2200">
+                <a:solidFill>
+                  <a:srgbClr val="2D2D2D"/>
+                </a:solidFill>
+                <a:latin typeface="Calibri"/>
               </a:defRPr>
             </a:pPr>
             <a:r>
-              <a:t>•  Random Forest achieves the best ranking: ROC-AUC 0.65, PR-AUC 0.014 (≈3× better than random at this positive rate).</a:t>
+              <a:t>•   RF achieves the best ranking: ROC-AUC 0.65, PR-AUC 0.014</a:t>
+            </a:r>
+            <a:br/>
+            <a:r>
+              <a:t>(≈3× better than random at this positive rate).</a:t>
             </a:r>
           </a:p>
           <a:p>
             <a:pPr>
+              <a:lnSpc>
+                <a:spcPts val="3000"/>
+              </a:lnSpc>
               <a:spcBef>
-                <a:spcPts val="800"/>
+                <a:spcPts val="1000"/>
               </a:spcBef>
-              <a:defRPr sz="2000" b="0">
-                <a:solidFill>
-                  <a:srgbClr val="444444"/>
-                </a:solidFill>
+              <a:defRPr sz="2200">
+                <a:solidFill>
+                  <a:srgbClr val="2D2D2D"/>
+                </a:solidFill>
+                <a:latin typeface="Calibri"/>
               </a:defRPr>
             </a:pPr>
             <a:r>
-              <a:t>•  Hotspot baseline captures some positives (recall 7.25%) but has low precision (2.74%). ARIMA improves ranking slightly (ROC-AUC 0.59).</a:t>
-            </a:r>
-          </a:p>
-          <a:p>
-            <a:pPr>
-              <a:spcBef>
-                <a:spcPts val="800"/>
-              </a:spcBef>
-              <a:defRPr sz="2000" b="0">
-                <a:solidFill>
-                  <a:srgbClr val="444444"/>
-                </a:solidFill>
-              </a:defRPr>
-            </a:pPr>
-            <a:r>
-              <a:t>•  RF threshold yields 0 true positives, but the probability surface is more informative — we use it as a continuous risk map, not an alarm.</a:t>
-            </a:r>
+              <a:t>•   RF threshold gives 0 true positives, but the continuous</a:t>
+            </a:r>
+            <a:br/>
+            <a:r>
+              <a:t>probability surface is more useful as a risk map.</a:t>
+            </a:r>
+          </a:p>
+        </p:txBody>
+      </p:sp>
+      <p:sp>
+        <p:nvSpPr>
+          <p:cNvPr id="32" name="Rounded Rectangle 31"/>
+          <p:cNvSpPr/>
+          <p:nvPr/>
+        </p:nvSpPr>
+        <p:spPr>
+          <a:xfrm>
+            <a:off x="13898880" y="8000999"/>
+            <a:ext cx="13075920" cy="6400800"/>
+          </a:xfrm>
+          <a:prstGeom prst="roundRect">
+            <a:avLst>
+              <a:gd name="adj" fmla="val 2000"/>
+            </a:avLst>
+          </a:prstGeom>
+          <a:solidFill>
+            <a:srgbClr val="F5F5F5"/>
+          </a:solidFill>
+          <a:ln w="12700">
+            <a:solidFill>
+              <a:srgbClr val="E0E0E0"/>
+            </a:solidFill>
+          </a:ln>
+        </p:spPr>
+        <p:style>
+          <a:lnRef idx="1">
+            <a:schemeClr val="accent1"/>
+          </a:lnRef>
+          <a:fillRef idx="3">
+            <a:schemeClr val="accent1"/>
+          </a:fillRef>
+          <a:effectRef idx="2">
+            <a:schemeClr val="accent1"/>
+          </a:effectRef>
+          <a:fontRef idx="minor">
+            <a:schemeClr val="lt1"/>
+          </a:fontRef>
+        </p:style>
+        <p:txBody>
+          <a:bodyPr rtlCol="0" anchor="ctr"/>
+          <a:lstStyle/>
+          <a:p>
+            <a:pPr algn="ctr"/>
           </a:p>
         </p:txBody>
       </p:sp>
       <p:pic>
         <p:nvPicPr>
-          <p:cNvPr id="25" name="Picture 24" descr="metrics_comparison.png"/>
+          <p:cNvPr id="33" name="Picture 32" descr="metrics_comparison.png"/>
           <p:cNvPicPr>
             <a:picLocks noChangeAspect="1"/>
           </p:cNvPicPr>
@@ -4175,8 +4608,8 @@
         </p:blipFill>
         <p:spPr>
           <a:xfrm>
-            <a:off x="14447520" y="7680960"/>
-            <a:ext cx="11704320" cy="6437376"/>
+            <a:off x="14950440" y="8275319"/>
+            <a:ext cx="10972800" cy="6035040"/>
           </a:xfrm>
           <a:prstGeom prst="rect">
             <a:avLst/>
@@ -4185,14 +4618,14 @@
       </p:pic>
       <p:sp>
         <p:nvSpPr>
-          <p:cNvPr id="26" name="TextBox 25"/>
+          <p:cNvPr id="34" name="TextBox 33"/>
           <p:cNvSpPr txBox="1"/>
           <p:nvPr/>
         </p:nvSpPr>
         <p:spPr>
           <a:xfrm>
-            <a:off x="14173200" y="14264640"/>
-            <a:ext cx="12618720" cy="457200"/>
+            <a:off x="14218920" y="13670280"/>
+            <a:ext cx="12435840" cy="365760"/>
           </a:xfrm>
           <a:prstGeom prst="rect">
             <a:avLst/>
@@ -4206,21 +4639,69 @@
           <a:lstStyle/>
           <a:p>
             <a:pPr algn="ctr">
-              <a:defRPr sz="1800" b="0">
-                <a:solidFill>
-                  <a:srgbClr val="444444"/>
-                </a:solidFill>
+              <a:defRPr sz="1600" i="1">
+                <a:solidFill>
+                  <a:srgbClr val="666666"/>
+                </a:solidFill>
+                <a:latin typeface="Calibri"/>
               </a:defRPr>
             </a:pPr>
             <a:r>
-              <a:t>Figure 3: Model comparison — key evaluation metrics</a:t>
-            </a:r>
+              <a:t>Fig. 3: Model comparison across key evaluation metrics</a:t>
+            </a:r>
+          </a:p>
+        </p:txBody>
+      </p:sp>
+      <p:sp>
+        <p:nvSpPr>
+          <p:cNvPr id="35" name="Rounded Rectangle 34"/>
+          <p:cNvSpPr/>
+          <p:nvPr/>
+        </p:nvSpPr>
+        <p:spPr>
+          <a:xfrm>
+            <a:off x="13898880" y="14721839"/>
+            <a:ext cx="13075920" cy="7863840"/>
+          </a:xfrm>
+          <a:prstGeom prst="roundRect">
+            <a:avLst>
+              <a:gd name="adj" fmla="val 2000"/>
+            </a:avLst>
+          </a:prstGeom>
+          <a:solidFill>
+            <a:srgbClr val="F5F5F5"/>
+          </a:solidFill>
+          <a:ln w="12700">
+            <a:solidFill>
+              <a:srgbClr val="E0E0E0"/>
+            </a:solidFill>
+          </a:ln>
+        </p:spPr>
+        <p:style>
+          <a:lnRef idx="1">
+            <a:schemeClr val="accent1"/>
+          </a:lnRef>
+          <a:fillRef idx="3">
+            <a:schemeClr val="accent1"/>
+          </a:fillRef>
+          <a:effectRef idx="2">
+            <a:schemeClr val="accent1"/>
+          </a:effectRef>
+          <a:fontRef idx="minor">
+            <a:schemeClr val="lt1"/>
+          </a:fontRef>
+        </p:style>
+        <p:txBody>
+          <a:bodyPr rtlCol="0" anchor="ctr"/>
+          <a:lstStyle/>
+          <a:p>
+            <a:pPr algn="ctr"/>
           </a:p>
         </p:txBody>
       </p:sp>
       <p:pic>
         <p:nvPicPr>
-          <p:cNvPr id="27" name="Picture 26" descr="roc_curves.png"/>
+          <p:cNvPr id="36" name="Picture 35" descr="roc_curves.png"/>
           <p:cNvPicPr>
             <a:picLocks noChangeAspect="1"/>
           </p:cNvPicPr>
@@ -4234,8 +4715,8 @@
         </p:blipFill>
         <p:spPr>
           <a:xfrm>
-            <a:off x="15544800" y="14996160"/>
-            <a:ext cx="9601200" cy="8229600"/>
+            <a:off x="16093440" y="14996159"/>
+            <a:ext cx="8686800" cy="7445829"/>
           </a:xfrm>
           <a:prstGeom prst="rect">
             <a:avLst/>
@@ -4244,14 +4725,14 @@
       </p:pic>
       <p:sp>
         <p:nvSpPr>
-          <p:cNvPr id="28" name="TextBox 27"/>
+          <p:cNvPr id="37" name="TextBox 36"/>
           <p:cNvSpPr txBox="1"/>
           <p:nvPr/>
         </p:nvSpPr>
         <p:spPr>
           <a:xfrm>
-            <a:off x="14173200" y="23225760"/>
-            <a:ext cx="12618720" cy="457200"/>
+            <a:off x="14218920" y="21945600"/>
+            <a:ext cx="12435840" cy="365760"/>
           </a:xfrm>
           <a:prstGeom prst="rect">
             <a:avLst/>
@@ -4265,72 +4746,42 @@
           <a:lstStyle/>
           <a:p>
             <a:pPr algn="ctr">
-              <a:defRPr sz="1800" b="0">
-                <a:solidFill>
-                  <a:srgbClr val="444444"/>
-                </a:solidFill>
+              <a:defRPr sz="1600" i="1">
+                <a:solidFill>
+                  <a:srgbClr val="666666"/>
+                </a:solidFill>
+                <a:latin typeface="Calibri"/>
               </a:defRPr>
             </a:pPr>
             <a:r>
-              <a:t>Figure 4: ROC curves for all three baseline models</a:t>
-            </a:r>
-          </a:p>
-        </p:txBody>
-      </p:sp>
-      <p:sp>
-        <p:nvSpPr>
-          <p:cNvPr id="29" name="TextBox 28"/>
-          <p:cNvSpPr txBox="1"/>
-          <p:nvPr/>
-        </p:nvSpPr>
-        <p:spPr>
-          <a:xfrm>
-            <a:off x="14173200" y="23865840"/>
-            <a:ext cx="12618720" cy="502920"/>
-          </a:xfrm>
-          <a:prstGeom prst="rect">
-            <a:avLst/>
-          </a:prstGeom>
-          <a:noFill/>
-        </p:spPr>
-        <p:txBody>
-          <a:bodyPr wrap="square">
-            <a:spAutoFit/>
-          </a:bodyPr>
-          <a:lstStyle/>
-          <a:p>
-            <a:pPr algn="l">
-              <a:defRPr sz="2800" b="1">
-                <a:solidFill>
-                  <a:srgbClr val="C0392B"/>
-                </a:solidFill>
-              </a:defRPr>
-            </a:pPr>
-            <a:r>
-              <a:t>Interpretability</a:t>
-            </a:r>
-          </a:p>
-        </p:txBody>
-      </p:sp>
-      <p:sp>
-        <p:nvSpPr>
-          <p:cNvPr id="30" name="Rectangle 29"/>
+              <a:t>Fig. 4: ROC curves for all three baseline models</a:t>
+            </a:r>
+          </a:p>
+        </p:txBody>
+      </p:sp>
+      <p:sp>
+        <p:nvSpPr>
+          <p:cNvPr id="38" name="Rounded Rectangle 37"/>
           <p:cNvSpPr/>
           <p:nvPr/>
         </p:nvSpPr>
         <p:spPr>
           <a:xfrm>
-            <a:off x="14173200" y="24323040"/>
-            <a:ext cx="12618720" cy="36576"/>
-          </a:xfrm>
-          <a:prstGeom prst="rect">
-            <a:avLst/>
+            <a:off x="13898880" y="22905719"/>
+            <a:ext cx="13075920" cy="9144000"/>
+          </a:xfrm>
+          <a:prstGeom prst="roundRect">
+            <a:avLst>
+              <a:gd name="adj" fmla="val 2000"/>
+            </a:avLst>
           </a:prstGeom>
           <a:solidFill>
-            <a:srgbClr val="C0392B"/>
+            <a:srgbClr val="F5F5F5"/>
           </a:solidFill>
-          <a:ln>
-            <a:noFill/>
+          <a:ln w="12700">
+            <a:solidFill>
+              <a:srgbClr val="E0E0E0"/>
+            </a:solidFill>
           </a:ln>
         </p:spPr>
         <p:style>
@@ -4357,14 +4808,57 @@
       </p:sp>
       <p:sp>
         <p:nvSpPr>
-          <p:cNvPr id="31" name="TextBox 30"/>
+          <p:cNvPr id="39" name="Rectangle 38"/>
+          <p:cNvSpPr/>
+          <p:nvPr/>
+        </p:nvSpPr>
+        <p:spPr>
+          <a:xfrm>
+            <a:off x="14218920" y="23225760"/>
+            <a:ext cx="109728" cy="457200"/>
+          </a:xfrm>
+          <a:prstGeom prst="rect">
+            <a:avLst/>
+          </a:prstGeom>
+          <a:solidFill>
+            <a:srgbClr val="B71C1C"/>
+          </a:solidFill>
+          <a:ln>
+            <a:noFill/>
+          </a:ln>
+        </p:spPr>
+        <p:style>
+          <a:lnRef idx="1">
+            <a:schemeClr val="accent1"/>
+          </a:lnRef>
+          <a:fillRef idx="3">
+            <a:schemeClr val="accent1"/>
+          </a:fillRef>
+          <a:effectRef idx="2">
+            <a:schemeClr val="accent1"/>
+          </a:effectRef>
+          <a:fontRef idx="minor">
+            <a:schemeClr val="lt1"/>
+          </a:fontRef>
+        </p:style>
+        <p:txBody>
+          <a:bodyPr rtlCol="0" anchor="ctr"/>
+          <a:lstStyle/>
+          <a:p>
+            <a:pPr algn="ctr"/>
+          </a:p>
+        </p:txBody>
+      </p:sp>
+      <p:sp>
+        <p:nvSpPr>
+          <p:cNvPr id="40" name="TextBox 39"/>
           <p:cNvSpPr txBox="1"/>
           <p:nvPr/>
         </p:nvSpPr>
         <p:spPr>
           <a:xfrm>
-            <a:off x="14173200" y="24414480"/>
-            <a:ext cx="12618720" cy="2011680"/>
+            <a:off x="14420088" y="23225760"/>
+            <a:ext cx="12234672" cy="502920"/>
           </a:xfrm>
           <a:prstGeom prst="rect">
             <a:avLst/>
@@ -4377,52 +4871,89 @@
           </a:bodyPr>
           <a:lstStyle/>
           <a:p>
-            <a:pPr algn="l">
-              <a:defRPr sz="2000" b="0">
-                <a:solidFill>
-                  <a:srgbClr val="444444"/>
-                </a:solidFill>
+            <a:pPr>
+              <a:defRPr sz="3200" b="1">
+                <a:solidFill>
+                  <a:srgbClr val="B71C1C"/>
+                </a:solidFill>
+                <a:latin typeface="Calibri"/>
               </a:defRPr>
             </a:pPr>
             <a:r>
-              <a:t>•  SHAP TreeExplainer on the RF model generates per-feature contributions for each cell-date prediction.</a:t>
-            </a:r>
-          </a:p>
+              <a:t>INTERPRETABILITY</a:t>
+            </a:r>
+          </a:p>
+        </p:txBody>
+      </p:sp>
+      <p:sp>
+        <p:nvSpPr>
+          <p:cNvPr id="41" name="TextBox 40"/>
+          <p:cNvSpPr txBox="1"/>
+          <p:nvPr/>
+        </p:nvSpPr>
+        <p:spPr>
+          <a:xfrm>
+            <a:off x="14218920" y="23820119"/>
+            <a:ext cx="12435840" cy="1828800"/>
+          </a:xfrm>
+          <a:prstGeom prst="rect">
+            <a:avLst/>
+          </a:prstGeom>
+          <a:noFill/>
+        </p:spPr>
+        <p:txBody>
+          <a:bodyPr wrap="square">
+            <a:spAutoFit/>
+          </a:bodyPr>
+          <a:lstStyle/>
           <a:p>
             <a:pPr>
+              <a:lnSpc>
+                <a:spcPts val="3000"/>
+              </a:lnSpc>
+              <a:defRPr sz="2200">
+                <a:solidFill>
+                  <a:srgbClr val="2D2D2D"/>
+                </a:solidFill>
+                <a:latin typeface="Calibri"/>
+              </a:defRPr>
+            </a:pPr>
+            <a:r>
+              <a:t>•   SHAP TreeExplainer on the RF model: per-feature</a:t>
+            </a:r>
+            <a:br/>
+            <a:r>
+              <a:t>contributions for every cell-date prediction.</a:t>
+            </a:r>
+          </a:p>
+          <a:p>
+            <a:pPr>
+              <a:lnSpc>
+                <a:spcPts val="3000"/>
+              </a:lnSpc>
               <a:spcBef>
-                <a:spcPts val="800"/>
+                <a:spcPts val="1000"/>
               </a:spcBef>
-              <a:defRPr sz="2000" b="0">
-                <a:solidFill>
-                  <a:srgbClr val="444444"/>
-                </a:solidFill>
+              <a:defRPr sz="2200">
+                <a:solidFill>
+                  <a:srgbClr val="2D2D2D"/>
+                </a:solidFill>
+                <a:latin typeface="Calibri"/>
               </a:defRPr>
             </a:pPr>
             <a:r>
-              <a:t>•  Top drivers for high-risk cells: rolling_sum_14, rolling_sum_7 (recent local activity), followed by month, wind, and grid location.</a:t>
-            </a:r>
-          </a:p>
-          <a:p>
-            <a:pPr>
-              <a:spcBef>
-                <a:spcPts val="800"/>
-              </a:spcBef>
-              <a:defRPr sz="2000" b="0">
-                <a:solidFill>
-                  <a:srgbClr val="444444"/>
-                </a:solidFill>
-              </a:defRPr>
-            </a:pPr>
-            <a:r>
-              <a:t>•  Narrative explanations are generated and displayed in the dashboard for every high-probability cell-date.</a:t>
+              <a:t>•   Top drivers: rolling_sum_14, rolling_sum_7 (recent activity),</a:t>
+            </a:r>
+            <a:br/>
+            <a:r>
+              <a:t>then month, wind, and grid location.</a:t>
             </a:r>
           </a:p>
         </p:txBody>
       </p:sp>
       <p:pic>
         <p:nvPicPr>
-          <p:cNvPr id="32" name="Picture 31" descr="shap_bar.png"/>
+          <p:cNvPr id="42" name="Picture 41" descr="shap_bar.png"/>
           <p:cNvPicPr>
             <a:picLocks noChangeAspect="1"/>
           </p:cNvPicPr>
@@ -4436,8 +4967,8 @@
         </p:blipFill>
         <p:spPr>
           <a:xfrm>
-            <a:off x="16002000" y="26609040"/>
-            <a:ext cx="8686800" cy="7703666"/>
+            <a:off x="16322040" y="25923239"/>
+            <a:ext cx="8229600" cy="7298209"/>
           </a:xfrm>
           <a:prstGeom prst="rect">
             <a:avLst/>
@@ -4446,14 +4977,14 @@
       </p:pic>
       <p:sp>
         <p:nvSpPr>
-          <p:cNvPr id="33" name="TextBox 32"/>
+          <p:cNvPr id="43" name="TextBox 42"/>
           <p:cNvSpPr txBox="1"/>
           <p:nvPr/>
         </p:nvSpPr>
         <p:spPr>
           <a:xfrm>
-            <a:off x="14173200" y="33832800"/>
-            <a:ext cx="12618720" cy="457200"/>
+            <a:off x="14218920" y="32324039"/>
+            <a:ext cx="12435840" cy="365760"/>
           </a:xfrm>
           <a:prstGeom prst="rect">
             <a:avLst/>
@@ -4467,72 +4998,42 @@
           <a:lstStyle/>
           <a:p>
             <a:pPr algn="ctr">
-              <a:defRPr sz="1800" b="0">
-                <a:solidFill>
-                  <a:srgbClr val="444444"/>
-                </a:solidFill>
+              <a:defRPr sz="1600" i="1">
+                <a:solidFill>
+                  <a:srgbClr val="666666"/>
+                </a:solidFill>
+                <a:latin typeface="Calibri"/>
               </a:defRPr>
             </a:pPr>
             <a:r>
-              <a:t>Figure 5: SHAP feature importance (mean |SHAP value|)</a:t>
-            </a:r>
-          </a:p>
-        </p:txBody>
-      </p:sp>
-      <p:sp>
-        <p:nvSpPr>
-          <p:cNvPr id="34" name="TextBox 33"/>
-          <p:cNvSpPr txBox="1"/>
-          <p:nvPr/>
-        </p:nvSpPr>
-        <p:spPr>
-          <a:xfrm>
-            <a:off x="14173200" y="34564320"/>
-            <a:ext cx="12618720" cy="502920"/>
-          </a:xfrm>
-          <a:prstGeom prst="rect">
-            <a:avLst/>
-          </a:prstGeom>
-          <a:noFill/>
-        </p:spPr>
-        <p:txBody>
-          <a:bodyPr wrap="square">
-            <a:spAutoFit/>
-          </a:bodyPr>
-          <a:lstStyle/>
-          <a:p>
-            <a:pPr algn="l">
-              <a:defRPr sz="2800" b="1">
-                <a:solidFill>
-                  <a:srgbClr val="C0392B"/>
-                </a:solidFill>
-              </a:defRPr>
-            </a:pPr>
-            <a:r>
-              <a:t>Conclusions</a:t>
-            </a:r>
-          </a:p>
-        </p:txBody>
-      </p:sp>
-      <p:sp>
-        <p:nvSpPr>
-          <p:cNvPr id="35" name="Rectangle 34"/>
+              <a:t>Fig. 5: SHAP feature importance (mean |SHAP value|)</a:t>
+            </a:r>
+          </a:p>
+        </p:txBody>
+      </p:sp>
+      <p:sp>
+        <p:nvSpPr>
+          <p:cNvPr id="44" name="Rounded Rectangle 43"/>
           <p:cNvSpPr/>
           <p:nvPr/>
         </p:nvSpPr>
         <p:spPr>
           <a:xfrm>
-            <a:off x="14173200" y="35021520"/>
-            <a:ext cx="12618720" cy="36576"/>
-          </a:xfrm>
-          <a:prstGeom prst="rect">
-            <a:avLst/>
+            <a:off x="13898880" y="32369760"/>
+            <a:ext cx="13075920" cy="3474720"/>
+          </a:xfrm>
+          <a:prstGeom prst="roundRect">
+            <a:avLst>
+              <a:gd name="adj" fmla="val 2000"/>
+            </a:avLst>
           </a:prstGeom>
           <a:solidFill>
-            <a:srgbClr val="C0392B"/>
+            <a:srgbClr val="F5F5F5"/>
           </a:solidFill>
-          <a:ln>
-            <a:noFill/>
+          <a:ln w="12700">
+            <a:solidFill>
+              <a:srgbClr val="E0E0E0"/>
+            </a:solidFill>
           </a:ln>
         </p:spPr>
         <p:style>
@@ -4559,14 +5060,57 @@
       </p:sp>
       <p:sp>
         <p:nvSpPr>
-          <p:cNvPr id="36" name="TextBox 35"/>
+          <p:cNvPr id="45" name="Rectangle 44"/>
+          <p:cNvSpPr/>
+          <p:nvPr/>
+        </p:nvSpPr>
+        <p:spPr>
+          <a:xfrm>
+            <a:off x="14218920" y="32689800"/>
+            <a:ext cx="109728" cy="457200"/>
+          </a:xfrm>
+          <a:prstGeom prst="rect">
+            <a:avLst/>
+          </a:prstGeom>
+          <a:solidFill>
+            <a:srgbClr val="B71C1C"/>
+          </a:solidFill>
+          <a:ln>
+            <a:noFill/>
+          </a:ln>
+        </p:spPr>
+        <p:style>
+          <a:lnRef idx="1">
+            <a:schemeClr val="accent1"/>
+          </a:lnRef>
+          <a:fillRef idx="3">
+            <a:schemeClr val="accent1"/>
+          </a:fillRef>
+          <a:effectRef idx="2">
+            <a:schemeClr val="accent1"/>
+          </a:effectRef>
+          <a:fontRef idx="minor">
+            <a:schemeClr val="lt1"/>
+          </a:fontRef>
+        </p:style>
+        <p:txBody>
+          <a:bodyPr rtlCol="0" anchor="ctr"/>
+          <a:lstStyle/>
+          <a:p>
+            <a:pPr algn="ctr"/>
+          </a:p>
+        </p:txBody>
+      </p:sp>
+      <p:sp>
+        <p:nvSpPr>
+          <p:cNvPr id="46" name="TextBox 45"/>
           <p:cNvSpPr txBox="1"/>
           <p:nvPr/>
         </p:nvSpPr>
         <p:spPr>
           <a:xfrm>
-            <a:off x="14173200" y="35112960"/>
-            <a:ext cx="12618720" cy="1828800"/>
+            <a:off x="14420088" y="32689800"/>
+            <a:ext cx="12234672" cy="502920"/>
           </a:xfrm>
           <a:prstGeom prst="rect">
             <a:avLst/>
@@ -4579,59 +5123,30 @@
           </a:bodyPr>
           <a:lstStyle/>
           <a:p>
-            <a:pPr algn="l">
-              <a:defRPr sz="1900" b="0">
-                <a:solidFill>
-                  <a:srgbClr val="444444"/>
-                </a:solidFill>
+            <a:pPr>
+              <a:defRPr sz="3200" b="1">
+                <a:solidFill>
+                  <a:srgbClr val="B71C1C"/>
+                </a:solidFill>
+                <a:latin typeface="Calibri"/>
               </a:defRPr>
             </a:pPr>
             <a:r>
-              <a:t>•  At 0.5% positive rate, binary metrics are insufficient — ranked risk surfaces are more useful than yes/no alarms.</a:t>
-            </a:r>
-          </a:p>
-          <a:p>
-            <a:pPr>
-              <a:spcBef>
-                <a:spcPts val="800"/>
-              </a:spcBef>
-              <a:defRPr sz="1900" b="0">
-                <a:solidFill>
-                  <a:srgbClr val="444444"/>
-                </a:solidFill>
-              </a:defRPr>
-            </a:pPr>
-            <a:r>
-              <a:t>•  Linked views (map + timeline + histogram + explanation) make model outputs easier to understand and critique than static heatmaps.</a:t>
-            </a:r>
-          </a:p>
-          <a:p>
-            <a:pPr>
-              <a:spcBef>
-                <a:spcPts val="800"/>
-              </a:spcBef>
-              <a:defRPr sz="1900" b="0">
-                <a:solidFill>
-                  <a:srgbClr val="444444"/>
-                </a:solidFill>
-              </a:defRPr>
-            </a:pPr>
-            <a:r>
-              <a:t>•  Future work: add census/land-use features, improve threshold calibration, try gradient boosting, conduct a formal user study.</a:t>
-            </a:r>
-          </a:p>
-        </p:txBody>
-      </p:sp>
-      <p:sp>
-        <p:nvSpPr>
-          <p:cNvPr id="37" name="TextBox 36"/>
+              <a:t>CONCLUSIONS</a:t>
+            </a:r>
+          </a:p>
+        </p:txBody>
+      </p:sp>
+      <p:sp>
+        <p:nvSpPr>
+          <p:cNvPr id="47" name="TextBox 46"/>
           <p:cNvSpPr txBox="1"/>
           <p:nvPr/>
         </p:nvSpPr>
         <p:spPr>
           <a:xfrm>
-            <a:off x="14173200" y="36210240"/>
-            <a:ext cx="12618720" cy="365760"/>
+            <a:off x="14218920" y="33284160"/>
+            <a:ext cx="12435840" cy="2377439"/>
           </a:xfrm>
           <a:prstGeom prst="rect">
             <a:avLst/>
@@ -4644,29 +5159,173 @@
           </a:bodyPr>
           <a:lstStyle/>
           <a:p>
-            <a:pPr algn="l">
-              <a:defRPr sz="2200" b="1">
-                <a:solidFill>
-                  <a:srgbClr val="C0392B"/>
-                </a:solidFill>
+            <a:pPr>
+              <a:lnSpc>
+                <a:spcPts val="3000"/>
+              </a:lnSpc>
+              <a:defRPr sz="2200">
+                <a:solidFill>
+                  <a:srgbClr val="2D2D2D"/>
+                </a:solidFill>
+                <a:latin typeface="Calibri"/>
               </a:defRPr>
             </a:pPr>
             <a:r>
-              <a:t>References</a:t>
-            </a:r>
-          </a:p>
-        </p:txBody>
-      </p:sp>
-      <p:sp>
-        <p:nvSpPr>
-          <p:cNvPr id="38" name="TextBox 37"/>
+              <a:t>•   Binary metrics are insufficient at 0.5% positive rate —</a:t>
+            </a:r>
+            <a:br/>
+            <a:r>
+              <a:t>ranked risk surfaces are more practical than alarms.</a:t>
+            </a:r>
+          </a:p>
+          <a:p>
+            <a:pPr>
+              <a:lnSpc>
+                <a:spcPts val="3000"/>
+              </a:lnSpc>
+              <a:spcBef>
+                <a:spcPts val="1000"/>
+              </a:spcBef>
+              <a:defRPr sz="2200">
+                <a:solidFill>
+                  <a:srgbClr val="2D2D2D"/>
+                </a:solidFill>
+                <a:latin typeface="Calibri"/>
+              </a:defRPr>
+            </a:pPr>
+            <a:r>
+              <a:t>•   Linked views (map + timeline + histogram + explanation)</a:t>
+            </a:r>
+            <a:br/>
+            <a:r>
+              <a:t>make model outputs easier to understand and critique.</a:t>
+            </a:r>
+          </a:p>
+          <a:p>
+            <a:pPr>
+              <a:lnSpc>
+                <a:spcPts val="3000"/>
+              </a:lnSpc>
+              <a:spcBef>
+                <a:spcPts val="1000"/>
+              </a:spcBef>
+              <a:defRPr sz="2200">
+                <a:solidFill>
+                  <a:srgbClr val="2D2D2D"/>
+                </a:solidFill>
+                <a:latin typeface="Calibri"/>
+              </a:defRPr>
+            </a:pPr>
+            <a:r>
+              <a:t>•   Future: census/land-use features, calibrated thresholds,</a:t>
+            </a:r>
+            <a:br/>
+            <a:r>
+              <a:t>gradient boosting, and a formal user study.</a:t>
+            </a:r>
+          </a:p>
+        </p:txBody>
+      </p:sp>
+      <p:sp>
+        <p:nvSpPr>
+          <p:cNvPr id="48" name="Rounded Rectangle 47"/>
+          <p:cNvSpPr/>
+          <p:nvPr/>
+        </p:nvSpPr>
+        <p:spPr>
+          <a:xfrm>
+            <a:off x="13898880" y="36164520"/>
+            <a:ext cx="13075920" cy="-45719"/>
+          </a:xfrm>
+          <a:prstGeom prst="roundRect">
+            <a:avLst>
+              <a:gd name="adj" fmla="val 2000"/>
+            </a:avLst>
+          </a:prstGeom>
+          <a:solidFill>
+            <a:srgbClr val="F5F5F5"/>
+          </a:solidFill>
+          <a:ln w="12700">
+            <a:solidFill>
+              <a:srgbClr val="E0E0E0"/>
+            </a:solidFill>
+          </a:ln>
+        </p:spPr>
+        <p:style>
+          <a:lnRef idx="1">
+            <a:schemeClr val="accent1"/>
+          </a:lnRef>
+          <a:fillRef idx="3">
+            <a:schemeClr val="accent1"/>
+          </a:fillRef>
+          <a:effectRef idx="2">
+            <a:schemeClr val="accent1"/>
+          </a:effectRef>
+          <a:fontRef idx="minor">
+            <a:schemeClr val="lt1"/>
+          </a:fontRef>
+        </p:style>
+        <p:txBody>
+          <a:bodyPr rtlCol="0" anchor="ctr"/>
+          <a:lstStyle/>
+          <a:p>
+            <a:pPr algn="ctr"/>
+          </a:p>
+        </p:txBody>
+      </p:sp>
+      <p:sp>
+        <p:nvSpPr>
+          <p:cNvPr id="49" name="Rectangle 48"/>
+          <p:cNvSpPr/>
+          <p:nvPr/>
+        </p:nvSpPr>
+        <p:spPr>
+          <a:xfrm>
+            <a:off x="14218920" y="36484560"/>
+            <a:ext cx="109728" cy="457200"/>
+          </a:xfrm>
+          <a:prstGeom prst="rect">
+            <a:avLst/>
+          </a:prstGeom>
+          <a:solidFill>
+            <a:srgbClr val="B71C1C"/>
+          </a:solidFill>
+          <a:ln>
+            <a:noFill/>
+          </a:ln>
+        </p:spPr>
+        <p:style>
+          <a:lnRef idx="1">
+            <a:schemeClr val="accent1"/>
+          </a:lnRef>
+          <a:fillRef idx="3">
+            <a:schemeClr val="accent1"/>
+          </a:fillRef>
+          <a:effectRef idx="2">
+            <a:schemeClr val="accent1"/>
+          </a:effectRef>
+          <a:fontRef idx="minor">
+            <a:schemeClr val="lt1"/>
+          </a:fontRef>
+        </p:style>
+        <p:txBody>
+          <a:bodyPr rtlCol="0" anchor="ctr"/>
+          <a:lstStyle/>
+          <a:p>
+            <a:pPr algn="ctr"/>
+          </a:p>
+        </p:txBody>
+      </p:sp>
+      <p:sp>
+        <p:nvSpPr>
+          <p:cNvPr id="50" name="TextBox 49"/>
           <p:cNvSpPr txBox="1"/>
           <p:nvPr/>
         </p:nvSpPr>
         <p:spPr>
           <a:xfrm>
-            <a:off x="14173200" y="36576000"/>
-            <a:ext cx="12618720" cy="731520"/>
+            <a:off x="14420088" y="36484560"/>
+            <a:ext cx="12234672" cy="502920"/>
           </a:xfrm>
           <a:prstGeom prst="rect">
             <a:avLst/>
@@ -4679,16 +5338,251 @@
           </a:bodyPr>
           <a:lstStyle/>
           <a:p>
-            <a:pPr algn="l">
-              <a:defRPr sz="1400" b="0">
-                <a:solidFill>
-                  <a:srgbClr val="444444"/>
-                </a:solidFill>
+            <a:pPr>
+              <a:defRPr sz="3200" b="1">
+                <a:solidFill>
+                  <a:srgbClr val="B71C1C"/>
+                </a:solidFill>
+                <a:latin typeface="Calibri"/>
               </a:defRPr>
             </a:pPr>
             <a:r>
-              <a:t>[1] Wang et al., CityGuard, ACM IMWUT 2019.  [2] Coffield et al., Fire size prediction, IJWF 2019.  [3] Lattimer et al., ML in fire simulation, FSJ 2020.  [4] Asgary et al., Toronto fire clustering, 2010.  [5] Yuan &amp; Wylie, ARIMA vs RF for Austin fires, 2024.  [6] Madaio et al., Firebird Atlanta, 2016.  [7] Jin et al., Deep sequence fire forecasting, ASC 2020.  [8] Ahn et al., Stacking ensemble fire risk, Fire 2024.  [9] Zhang et al., Firefighter demand prediction, FSJ 2024.  [10] Ku et al., GIS fire drivers, 2024.  [11] Cui et al., Ensemble fire risk, IJDRR 2024.  [12] Liao et al., Residential fire factors, 2024.  [13] Kang et al., GIS+ML fire risk, Sustainability 2018.  [14] Xiao et al., Spatial fire hazard, AAP 2018.  [15] Jennings, Socioeconomic fire risk, FSJ 2013.</a:t>
-            </a:r>
+              <a:t>REFERENCES</a:t>
+            </a:r>
+          </a:p>
+        </p:txBody>
+      </p:sp>
+      <p:sp>
+        <p:nvSpPr>
+          <p:cNvPr id="51" name="TextBox 50"/>
+          <p:cNvSpPr txBox="1"/>
+          <p:nvPr/>
+        </p:nvSpPr>
+        <p:spPr>
+          <a:xfrm>
+            <a:off x="14218920" y="37078920"/>
+            <a:ext cx="12435840" cy="-960119"/>
+          </a:xfrm>
+          <a:prstGeom prst="rect">
+            <a:avLst/>
+          </a:prstGeom>
+          <a:noFill/>
+        </p:spPr>
+        <p:txBody>
+          <a:bodyPr wrap="square">
+            <a:spAutoFit/>
+          </a:bodyPr>
+          <a:lstStyle/>
+          <a:p>
+            <a:pPr>
+              <a:lnSpc>
+                <a:spcPts val="2400"/>
+              </a:lnSpc>
+              <a:defRPr sz="1600">
+                <a:solidFill>
+                  <a:srgbClr val="2D2D2D"/>
+                </a:solidFill>
+                <a:latin typeface="Calibri"/>
+              </a:defRPr>
+            </a:pPr>
+            <a:r>
+              <a:t>•   [1] Wang et al., CityGuard, IMWUT 2019</a:t>
+            </a:r>
+          </a:p>
+          <a:p>
+            <a:pPr>
+              <a:lnSpc>
+                <a:spcPts val="2400"/>
+              </a:lnSpc>
+              <a:spcBef>
+                <a:spcPts val="1000"/>
+              </a:spcBef>
+              <a:defRPr sz="1600">
+                <a:solidFill>
+                  <a:srgbClr val="2D2D2D"/>
+                </a:solidFill>
+                <a:latin typeface="Calibri"/>
+              </a:defRPr>
+            </a:pPr>
+            <a:r>
+              <a:t>•   [2] Coffield et al., Fire size ML, IJWF 2019</a:t>
+            </a:r>
+          </a:p>
+          <a:p>
+            <a:pPr>
+              <a:lnSpc>
+                <a:spcPts val="2400"/>
+              </a:lnSpc>
+              <a:spcBef>
+                <a:spcPts val="1000"/>
+              </a:spcBef>
+              <a:defRPr sz="1600">
+                <a:solidFill>
+                  <a:srgbClr val="2D2D2D"/>
+                </a:solidFill>
+                <a:latin typeface="Calibri"/>
+              </a:defRPr>
+            </a:pPr>
+            <a:r>
+              <a:t>•   [3] Lattimer et al., ML fire simulation, FSJ 2020</a:t>
+            </a:r>
+          </a:p>
+          <a:p>
+            <a:pPr>
+              <a:lnSpc>
+                <a:spcPts val="2400"/>
+              </a:lnSpc>
+              <a:spcBef>
+                <a:spcPts val="1000"/>
+              </a:spcBef>
+              <a:defRPr sz="1600">
+                <a:solidFill>
+                  <a:srgbClr val="2D2D2D"/>
+                </a:solidFill>
+                <a:latin typeface="Calibri"/>
+              </a:defRPr>
+            </a:pPr>
+            <a:r>
+              <a:t>•   [4] Asgary et al., Toronto fire clustering, 2010</a:t>
+            </a:r>
+          </a:p>
+          <a:p>
+            <a:pPr>
+              <a:lnSpc>
+                <a:spcPts val="2400"/>
+              </a:lnSpc>
+              <a:spcBef>
+                <a:spcPts val="1000"/>
+              </a:spcBef>
+              <a:defRPr sz="1600">
+                <a:solidFill>
+                  <a:srgbClr val="2D2D2D"/>
+                </a:solidFill>
+                <a:latin typeface="Calibri"/>
+              </a:defRPr>
+            </a:pPr>
+            <a:r>
+              <a:t>•   [5] Yuan &amp; Wylie, ARIMA vs RF, Austin 2024</a:t>
+            </a:r>
+          </a:p>
+          <a:p>
+            <a:pPr>
+              <a:lnSpc>
+                <a:spcPts val="2400"/>
+              </a:lnSpc>
+              <a:spcBef>
+                <a:spcPts val="1000"/>
+              </a:spcBef>
+              <a:defRPr sz="1600">
+                <a:solidFill>
+                  <a:srgbClr val="2D2D2D"/>
+                </a:solidFill>
+                <a:latin typeface="Calibri"/>
+              </a:defRPr>
+            </a:pPr>
+            <a:r>
+              <a:t>•   [6] Madaio et al., Firebird Atlanta, 2016</a:t>
+            </a:r>
+          </a:p>
+          <a:p>
+            <a:pPr>
+              <a:lnSpc>
+                <a:spcPts val="2400"/>
+              </a:lnSpc>
+              <a:spcBef>
+                <a:spcPts val="1000"/>
+              </a:spcBef>
+              <a:defRPr sz="1600">
+                <a:solidFill>
+                  <a:srgbClr val="2D2D2D"/>
+                </a:solidFill>
+                <a:latin typeface="Calibri"/>
+              </a:defRPr>
+            </a:pPr>
+            <a:r>
+              <a:t>•   [7] Jin et al., Deep sequence fire, ASC 2020</a:t>
+            </a:r>
+          </a:p>
+          <a:p>
+            <a:pPr>
+              <a:lnSpc>
+                <a:spcPts val="2400"/>
+              </a:lnSpc>
+              <a:spcBef>
+                <a:spcPts val="1000"/>
+              </a:spcBef>
+              <a:defRPr sz="1600">
+                <a:solidFill>
+                  <a:srgbClr val="2D2D2D"/>
+                </a:solidFill>
+                <a:latin typeface="Calibri"/>
+              </a:defRPr>
+            </a:pPr>
+            <a:r>
+              <a:t>•   [8] Ahn et al., Stacking ensemble, Fire 2024</a:t>
+            </a:r>
+          </a:p>
+          <a:p>
+            <a:pPr>
+              <a:lnSpc>
+                <a:spcPts val="2400"/>
+              </a:lnSpc>
+              <a:spcBef>
+                <a:spcPts val="1000"/>
+              </a:spcBef>
+              <a:defRPr sz="1600">
+                <a:solidFill>
+                  <a:srgbClr val="2D2D2D"/>
+                </a:solidFill>
+                <a:latin typeface="Calibri"/>
+              </a:defRPr>
+            </a:pPr>
+            <a:r>
+              <a:t>•   [9–15] Zhang, Ku, Cui, Liao, Kang, Xiao, Jennings</a:t>
+            </a:r>
+          </a:p>
+        </p:txBody>
+      </p:sp>
+      <p:sp>
+        <p:nvSpPr>
+          <p:cNvPr id="52" name="Rectangle 51"/>
+          <p:cNvSpPr/>
+          <p:nvPr/>
+        </p:nvSpPr>
+        <p:spPr>
+          <a:xfrm>
+            <a:off x="0" y="36411408"/>
+            <a:ext cx="27432000" cy="164592"/>
+          </a:xfrm>
+          <a:prstGeom prst="rect">
+            <a:avLst/>
+          </a:prstGeom>
+          <a:solidFill>
+            <a:srgbClr val="B71C1C"/>
+          </a:solidFill>
+          <a:ln>
+            <a:noFill/>
+          </a:ln>
+        </p:spPr>
+        <p:style>
+          <a:lnRef idx="1">
+            <a:schemeClr val="accent1"/>
+          </a:lnRef>
+          <a:fillRef idx="3">
+            <a:schemeClr val="accent1"/>
+          </a:fillRef>
+          <a:effectRef idx="2">
+            <a:schemeClr val="accent1"/>
+          </a:effectRef>
+          <a:fontRef idx="minor">
+            <a:schemeClr val="lt1"/>
+          </a:fontRef>
+        </p:style>
+        <p:txBody>
+          <a:bodyPr rtlCol="0" anchor="ctr"/>
+          <a:lstStyle/>
+          <a:p>
+            <a:pPr algn="ctr"/>
           </a:p>
         </p:txBody>
       </p:sp>

</xml_diff>

<commit_message>
Fill rubric gaps in poster: add why-it-matters and novelty bullets
</commit_message>
<xml_diff>
--- a/docs/team046poster.pptx
+++ b/docs/team046poster.pptx
@@ -3312,7 +3312,7 @@
         <p:spPr>
           <a:xfrm>
             <a:off x="457200" y="3474720"/>
-            <a:ext cx="13075920" cy="4206240"/>
+            <a:ext cx="13075920" cy="5303520"/>
           </a:xfrm>
           <a:prstGeom prst="roundRect">
             <a:avLst>
@@ -3438,7 +3438,7 @@
         <p:spPr>
           <a:xfrm>
             <a:off x="777240" y="4389120"/>
-            <a:ext cx="12435840" cy="2926079"/>
+            <a:ext cx="12435840" cy="4023360"/>
           </a:xfrm>
           <a:prstGeom prst="rect">
             <a:avLst/>
@@ -3463,11 +3463,15 @@
               </a:defRPr>
             </a:pPr>
             <a:r>
-              <a:t>•   Fire departments make readiness decisions under uncertainty,</a:t>
+              <a:t>•   Fire departments make staffing and inspection decisions</a:t>
             </a:r>
             <a:br/>
             <a:r>
-              <a:t>yet incidents are not uniformly distributed across a city.</a:t>
+              <a:t>under uncertainty, yet fire incidents cluster unevenly</a:t>
+            </a:r>
+            <a:br/>
+            <a:r>
+              <a:t>across neighborhoods and time periods.</a:t>
             </a:r>
           </a:p>
           <a:p>
@@ -3490,7 +3494,11 @@
             </a:r>
             <a:br/>
             <a:r>
-              <a:t>concentrated, how it changes, or why an area is flagged.</a:t>
+              <a:t>concentrated, how it shifts over time, or why a model</a:t>
+            </a:r>
+            <a:br/>
+            <a:r>
+              <a:t>flags a particular area.</a:t>
             </a:r>
           </a:p>
           <a:p>
@@ -3509,11 +3517,42 @@
               </a:defRPr>
             </a:pPr>
             <a:r>
-              <a:t>•   We built an end-to-end system that forecasts next-day fire</a:t>
+              <a:t>•   Better risk awareness helps departments pre-position</a:t>
             </a:r>
             <a:br/>
             <a:r>
-              <a:t>risk on a 1 km Atlanta grid and explains each prediction.</a:t>
+              <a:t>resources and prioritize inspections, potentially</a:t>
+            </a:r>
+            <a:br/>
+            <a:r>
+              <a:t>reducing response times and preventing incidents.</a:t>
+            </a:r>
+          </a:p>
+          <a:p>
+            <a:pPr>
+              <a:lnSpc>
+                <a:spcPts val="3000"/>
+              </a:lnSpc>
+              <a:spcBef>
+                <a:spcPts val="1000"/>
+              </a:spcBef>
+              <a:defRPr sz="2200">
+                <a:solidFill>
+                  <a:srgbClr val="2D2D2D"/>
+                </a:solidFill>
+                <a:latin typeface="Calibri"/>
+              </a:defRPr>
+            </a:pPr>
+            <a:r>
+              <a:t>•   We built an end-to-end system that forecasts next-day</a:t>
+            </a:r>
+            <a:br/>
+            <a:r>
+              <a:t>fire risk on a 1 km Atlanta grid and explains each</a:t>
+            </a:r>
+            <a:br/>
+            <a:r>
+              <a:t>prediction through an interactive dashboard.</a:t>
             </a:r>
           </a:p>
         </p:txBody>
@@ -3526,8 +3565,8 @@
         </p:nvSpPr>
         <p:spPr>
           <a:xfrm>
-            <a:off x="457200" y="8000999"/>
-            <a:ext cx="13075920" cy="4023360"/>
+            <a:off x="457200" y="9098280"/>
+            <a:ext cx="13075920" cy="3840480"/>
           </a:xfrm>
           <a:prstGeom prst="roundRect">
             <a:avLst>
@@ -3573,7 +3612,7 @@
         </p:nvSpPr>
         <p:spPr>
           <a:xfrm>
-            <a:off x="777240" y="8321039"/>
+            <a:off x="777240" y="9418319"/>
             <a:ext cx="109728" cy="457200"/>
           </a:xfrm>
           <a:prstGeom prst="rect">
@@ -3616,7 +3655,7 @@
         </p:nvSpPr>
         <p:spPr>
           <a:xfrm>
-            <a:off x="978408" y="8321039"/>
+            <a:off x="978408" y="9418319"/>
             <a:ext cx="12234672" cy="502920"/>
           </a:xfrm>
           <a:prstGeom prst="rect">
@@ -3652,8 +3691,8 @@
         </p:nvSpPr>
         <p:spPr>
           <a:xfrm>
-            <a:off x="777240" y="8915399"/>
-            <a:ext cx="12435840" cy="2743200"/>
+            <a:off x="777240" y="10012680"/>
+            <a:ext cx="12435840" cy="2560320"/>
           </a:xfrm>
           <a:prstGeom prst="rect">
             <a:avLst/>
@@ -3741,8 +3780,8 @@
         </p:nvSpPr>
         <p:spPr>
           <a:xfrm>
-            <a:off x="457200" y="12344399"/>
-            <a:ext cx="13075920" cy="6583680"/>
+            <a:off x="457200" y="13258799"/>
+            <a:ext cx="13075920" cy="7498079"/>
           </a:xfrm>
           <a:prstGeom prst="roundRect">
             <a:avLst>
@@ -3788,7 +3827,7 @@
         </p:nvSpPr>
         <p:spPr>
           <a:xfrm>
-            <a:off x="777240" y="12664439"/>
+            <a:off x="777240" y="13578839"/>
             <a:ext cx="109728" cy="457200"/>
           </a:xfrm>
           <a:prstGeom prst="rect">
@@ -3831,7 +3870,7 @@
         </p:nvSpPr>
         <p:spPr>
           <a:xfrm>
-            <a:off x="978408" y="12664439"/>
+            <a:off x="978408" y="13578839"/>
             <a:ext cx="12234672" cy="502920"/>
           </a:xfrm>
           <a:prstGeom prst="rect">
@@ -3867,8 +3906,8 @@
         </p:nvSpPr>
         <p:spPr>
           <a:xfrm>
-            <a:off x="777240" y="13258799"/>
-            <a:ext cx="12435840" cy="5303520"/>
+            <a:off x="777240" y="14173199"/>
+            <a:ext cx="12435840" cy="6217919"/>
           </a:xfrm>
           <a:prstGeom prst="rect">
             <a:avLst/>
@@ -3945,6 +3984,14 @@
             <a:r>
               <a:t>balanced weights. Uses all 14 features + encoded grid_id.</a:t>
             </a:r>
+            <a:br/>
+            <a:r>
+              <a:t>Combines weather, calendar, history, and location signals</a:t>
+            </a:r>
+            <a:br/>
+            <a:r>
+              <a:t>that simpler baselines ignore individually.</a:t>
+            </a:r>
           </a:p>
           <a:p>
             <a:pPr>
@@ -3969,6 +4016,33 @@
               <a:t>No row shuffling to prevent future-data leakage.</a:t>
             </a:r>
           </a:p>
+          <a:p>
+            <a:pPr>
+              <a:lnSpc>
+                <a:spcPts val="3000"/>
+              </a:lnSpc>
+              <a:spcBef>
+                <a:spcPts val="1000"/>
+              </a:spcBef>
+              <a:defRPr sz="2200">
+                <a:solidFill>
+                  <a:srgbClr val="2D2D2D"/>
+                </a:solidFill>
+                <a:latin typeface="Calibri"/>
+              </a:defRPr>
+            </a:pPr>
+            <a:r>
+              <a:t>•   Key novelty: most prior systems provide either forecasting</a:t>
+            </a:r>
+            <a:br/>
+            <a:r>
+              <a:t>or explanation. Ours combines short-horizon prediction,</a:t>
+            </a:r>
+            <a:br/>
+            <a:r>
+              <a:t>SHAP explanation, and interactive exploration in one tool.</a:t>
+            </a:r>
+          </a:p>
         </p:txBody>
       </p:sp>
       <p:sp>
@@ -3979,7 +4053,7 @@
         </p:nvSpPr>
         <p:spPr>
           <a:xfrm>
-            <a:off x="457200" y="19248120"/>
+            <a:off x="457200" y="21076919"/>
             <a:ext cx="13075920" cy="8686800"/>
           </a:xfrm>
           <a:prstGeom prst="roundRect">
@@ -4034,7 +4108,7 @@
         </p:blipFill>
         <p:spPr>
           <a:xfrm>
-            <a:off x="3337560" y="19522440"/>
+            <a:off x="3337560" y="21351239"/>
             <a:ext cx="7315200" cy="7716390"/>
           </a:xfrm>
           <a:prstGeom prst="rect">
@@ -4050,7 +4124,7 @@
         </p:nvSpPr>
         <p:spPr>
           <a:xfrm>
-            <a:off x="777240" y="27157680"/>
+            <a:off x="777240" y="28986479"/>
             <a:ext cx="12435840" cy="365760"/>
           </a:xfrm>
           <a:prstGeom prst="rect">
@@ -4086,8 +4160,8 @@
         </p:nvSpPr>
         <p:spPr>
           <a:xfrm>
-            <a:off x="457200" y="28254960"/>
-            <a:ext cx="13075920" cy="7863839"/>
+            <a:off x="457200" y="30083760"/>
+            <a:ext cx="13075920" cy="6035040"/>
           </a:xfrm>
           <a:prstGeom prst="roundRect">
             <a:avLst>
@@ -4133,7 +4207,7 @@
         </p:nvSpPr>
         <p:spPr>
           <a:xfrm>
-            <a:off x="777240" y="28575000"/>
+            <a:off x="777240" y="30403800"/>
             <a:ext cx="109728" cy="457200"/>
           </a:xfrm>
           <a:prstGeom prst="rect">
@@ -4176,7 +4250,7 @@
         </p:nvSpPr>
         <p:spPr>
           <a:xfrm>
-            <a:off x="978408" y="28575000"/>
+            <a:off x="978408" y="30403800"/>
             <a:ext cx="12234672" cy="502920"/>
           </a:xfrm>
           <a:prstGeom prst="rect">
@@ -4212,7 +4286,7 @@
         </p:nvSpPr>
         <p:spPr>
           <a:xfrm>
-            <a:off x="777240" y="29169360"/>
+            <a:off x="777240" y="30998160"/>
             <a:ext cx="12435840" cy="2743200"/>
           </a:xfrm>
           <a:prstGeom prst="rect">
@@ -4286,7 +4360,7 @@
         </p:blipFill>
         <p:spPr>
           <a:xfrm>
-            <a:off x="1280160" y="32095440"/>
+            <a:off x="1280160" y="33924240"/>
             <a:ext cx="11430000" cy="7347857"/>
           </a:xfrm>
           <a:prstGeom prst="rect">
@@ -4302,7 +4376,7 @@
         </p:nvSpPr>
         <p:spPr>
           <a:xfrm>
-            <a:off x="777240" y="39227760"/>
+            <a:off x="777240" y="41056560"/>
             <a:ext cx="12435840" cy="365760"/>
           </a:xfrm>
           <a:prstGeom prst="rect">

</xml_diff>

<commit_message>
Remove em dashes from report and poster, strengthen rubric coverage
</commit_message>
<xml_diff>
--- a/docs/team046poster.pptx
+++ b/docs/team046poster.pptx
@@ -3298,7 +3298,7 @@
               </a:defRPr>
             </a:pPr>
             <a:r>
-              <a:t>Georgia Institute of Technology  —  CSE 6242 Data and Visual Analytics  —  Team 46</a:t>
+              <a:t>Georgia Institute of Technology  |  CSE 6242 Data and Visual Analytics  |  Team 46</a:t>
             </a:r>
           </a:p>
         </p:txBody>
@@ -3463,15 +3463,15 @@
               </a:defRPr>
             </a:pPr>
             <a:r>
-              <a:t>•   Fire departments make staffing and inspection decisions</a:t>
+              <a:t>•   Problem: Fire departments make staffing and inspection</a:t>
             </a:r>
             <a:br/>
             <a:r>
-              <a:t>under uncertainty, yet fire incidents cluster unevenly</a:t>
+              <a:t>decisions under uncertainty, yet fire incidents cluster</a:t>
             </a:r>
             <a:br/>
             <a:r>
-              <a:t>across neighborhoods and time periods.</a:t>
+              <a:t>unevenly across neighborhoods and time periods.</a:t>
             </a:r>
           </a:p>
           <a:p>
@@ -3490,7 +3490,7 @@
               </a:defRPr>
             </a:pPr>
             <a:r>
-              <a:t>•   Current tools show what happened — not where risk is</a:t>
+              <a:t>•   Current tools show what happened, but not where risk is</a:t>
             </a:r>
             <a:br/>
             <a:r>
@@ -3517,15 +3517,15 @@
               </a:defRPr>
             </a:pPr>
             <a:r>
-              <a:t>•   Better risk awareness helps departments pre-position</a:t>
+              <a:t>•   Why it matters: Better risk awareness helps departments</a:t>
             </a:r>
             <a:br/>
             <a:r>
-              <a:t>resources and prioritize inspections, potentially</a:t>
+              <a:t>pre-position resources, prioritize inspections, and</a:t>
             </a:r>
             <a:br/>
             <a:r>
-              <a:t>reducing response times and preventing incidents.</a:t>
+              <a:t>potentially reduce response times.</a:t>
             </a:r>
           </a:p>
           <a:p>
@@ -3544,15 +3544,15 @@
               </a:defRPr>
             </a:pPr>
             <a:r>
-              <a:t>•   We built an end-to-end system that forecasts next-day</a:t>
+              <a:t>•   Our system forecasts next-day fire risk on a 1 km</a:t>
             </a:r>
             <a:br/>
             <a:r>
-              <a:t>fire risk on a 1 km Atlanta grid and explains each</a:t>
+              <a:t>Atlanta grid and explains each prediction through</a:t>
             </a:r>
             <a:br/>
             <a:r>
-              <a:t>prediction through an interactive dashboard.</a:t>
+              <a:t>an interactive Leaflet/D3 dashboard.</a:t>
             </a:r>
           </a:p>
         </p:txBody>
@@ -3721,7 +3721,7 @@
             </a:r>
             <a:br/>
             <a:r>
-              <a:t>(Atlanta, fire codes 100–199, deduplicated).</a:t>
+              <a:t>(Atlanta, fire codes 100-199, deduplicated).</a:t>
             </a:r>
           </a:p>
           <a:p>
@@ -3936,7 +3936,11 @@
             </a:r>
             <a:br/>
             <a:r>
-              <a:t>weighted by count. Captures static spatial density only.</a:t>
+              <a:t>weighted by count. Tests if static spatial density alone</a:t>
+            </a:r>
+            <a:br/>
+            <a:r>
+              <a:t>can identify future risk.</a:t>
             </a:r>
           </a:p>
           <a:p>
@@ -3959,7 +3963,11 @@
             </a:r>
             <a:br/>
             <a:r>
-              <a:t>Grid search (p,d,q) by AIC; fallback for sparse cells.</a:t>
+              <a:t>Grid search (p,d,q) by AIC. Tests whether a cell's own</a:t>
+            </a:r>
+            <a:br/>
+            <a:r>
+              <a:t>history predicts its future activity.</a:t>
             </a:r>
           </a:p>
           <a:p>
@@ -3982,15 +3990,15 @@
             </a:r>
             <a:br/>
             <a:r>
-              <a:t>balanced weights. Uses all 14 features + encoded grid_id.</a:t>
+              <a:t>balanced weights, 14 features + encoded grid_id.</a:t>
             </a:r>
             <a:br/>
             <a:r>
-              <a:t>Combines weather, calendar, history, and location signals</a:t>
+              <a:t>Intuition: combining weather, calendar, recent history,</a:t>
             </a:r>
             <a:br/>
             <a:r>
-              <a:t>that simpler baselines ignore individually.</a:t>
+              <a:t>and location should outperform single-signal baselines.</a:t>
             </a:r>
           </a:p>
           <a:p>
@@ -4009,7 +4017,7 @@
               </a:defRPr>
             </a:pPr>
             <a:r>
-              <a:t>•   Temporal 80/20 split: train Jan–Oct 18, test Oct 19–Dec 30.</a:t>
+              <a:t>•   Temporal 80/20 split: train Jan-Oct 18, test Oct 19-Dec 30.</a:t>
             </a:r>
             <a:br/>
             <a:r>
@@ -4032,15 +4040,15 @@
               </a:defRPr>
             </a:pPr>
             <a:r>
-              <a:t>•   Key novelty: most prior systems provide either forecasting</a:t>
+              <a:t>•   Novelty: most prior systems offer forecasting or</a:t>
             </a:r>
             <a:br/>
             <a:r>
-              <a:t>or explanation. Ours combines short-horizon prediction,</a:t>
+              <a:t>explanation, not both. Ours integrates prediction,</a:t>
             </a:r>
             <a:br/>
             <a:r>
-              <a:t>SHAP explanation, and interactive exploration in one tool.</a:t>
+              <a:t>SHAP explanation, and linked exploration in one tool.</a:t>
             </a:r>
           </a:p>
         </p:txBody>
@@ -4413,7 +4421,7 @@
         <p:spPr>
           <a:xfrm>
             <a:off x="13898880" y="3474720"/>
-            <a:ext cx="13075920" cy="4206240"/>
+            <a:ext cx="13075920" cy="4754880"/>
           </a:xfrm>
           <a:prstGeom prst="roundRect">
             <a:avLst>
@@ -4539,7 +4547,7 @@
         <p:spPr>
           <a:xfrm>
             <a:off x="14218920" y="4389120"/>
-            <a:ext cx="12435840" cy="3291840"/>
+            <a:ext cx="12435840" cy="3840480"/>
           </a:xfrm>
           <a:prstGeom prst="rect">
             <a:avLst/>
@@ -4564,11 +4572,11 @@
               </a:defRPr>
             </a:pPr>
             <a:r>
-              <a:t>•   Test set: 26,572 cell-days, only 138 positive (0.52%).</a:t>
+              <a:t>•   Evaluation: temporal hold-out (last 20% of dates).</a:t>
             </a:r>
             <a:br/>
             <a:r>
-              <a:t>Extreme imbalance makes accuracy misleading (all &gt; 98%).</a:t>
+              <a:t>Metrics: Accuracy, Precision, Recall, F1, ROC-AUC, PR-AUC.</a:t>
             </a:r>
           </a:p>
           <a:p>
@@ -4587,11 +4595,11 @@
               </a:defRPr>
             </a:pPr>
             <a:r>
-              <a:t>•   RF achieves the best ranking: ROC-AUC 0.65, PR-AUC 0.014</a:t>
+              <a:t>•   Test set: 26,572 cell-days, only 138 positive (0.52%).</a:t>
             </a:r>
             <a:br/>
             <a:r>
-              <a:t>(≈3× better than random at this positive rate).</a:t>
+              <a:t>Extreme imbalance makes accuracy misleading (all &gt; 98%).</a:t>
             </a:r>
           </a:p>
           <a:p>
@@ -4610,11 +4618,38 @@
               </a:defRPr>
             </a:pPr>
             <a:r>
-              <a:t>•   RF threshold gives 0 true positives, but the continuous</a:t>
+              <a:t>•   Model comparison: RF outranks both baselines.</a:t>
             </a:r>
             <a:br/>
             <a:r>
-              <a:t>probability surface is more useful as a risk map.</a:t>
+              <a:t>ROC-AUC: RF 0.65 &gt; ARIMA 0.59 &gt; Hotspot 0.53.</a:t>
+            </a:r>
+            <a:br/>
+            <a:r>
+              <a:t>PR-AUC:  RF 0.014 &gt; ARIMA 0.011 &gt; Hotspot 0.009.</a:t>
+            </a:r>
+          </a:p>
+          <a:p>
+            <a:pPr>
+              <a:lnSpc>
+                <a:spcPts val="3000"/>
+              </a:lnSpc>
+              <a:spcBef>
+                <a:spcPts val="1000"/>
+              </a:spcBef>
+              <a:defRPr sz="2200">
+                <a:solidFill>
+                  <a:srgbClr val="2D2D2D"/>
+                </a:solidFill>
+                <a:latin typeface="Calibri"/>
+              </a:defRPr>
+            </a:pPr>
+            <a:r>
+              <a:t>•   RF threshold yields 0 true positives, but the continuous</a:t>
+            </a:r>
+            <a:br/>
+            <a:r>
+              <a:t>probability surface is more useful as a ranked risk map.</a:t>
             </a:r>
           </a:p>
         </p:txBody>
@@ -4627,7 +4662,7 @@
         </p:nvSpPr>
         <p:spPr>
           <a:xfrm>
-            <a:off x="13898880" y="8000999"/>
+            <a:off x="13898880" y="8549640"/>
             <a:ext cx="13075920" cy="6400800"/>
           </a:xfrm>
           <a:prstGeom prst="roundRect">
@@ -4682,7 +4717,7 @@
         </p:blipFill>
         <p:spPr>
           <a:xfrm>
-            <a:off x="14950440" y="8275319"/>
+            <a:off x="14950440" y="8823960"/>
             <a:ext cx="10972800" cy="6035040"/>
           </a:xfrm>
           <a:prstGeom prst="rect">
@@ -4698,7 +4733,7 @@
         </p:nvSpPr>
         <p:spPr>
           <a:xfrm>
-            <a:off x="14218920" y="13670280"/>
+            <a:off x="14218920" y="14218920"/>
             <a:ext cx="12435840" cy="365760"/>
           </a:xfrm>
           <a:prstGeom prst="rect">
@@ -4734,7 +4769,7 @@
         </p:nvSpPr>
         <p:spPr>
           <a:xfrm>
-            <a:off x="13898880" y="14721839"/>
+            <a:off x="13898880" y="15270480"/>
             <a:ext cx="13075920" cy="7863840"/>
           </a:xfrm>
           <a:prstGeom prst="roundRect">
@@ -4789,7 +4824,7 @@
         </p:blipFill>
         <p:spPr>
           <a:xfrm>
-            <a:off x="16093440" y="14996159"/>
+            <a:off x="16093440" y="15544800"/>
             <a:ext cx="8686800" cy="7445829"/>
           </a:xfrm>
           <a:prstGeom prst="rect">
@@ -4805,7 +4840,7 @@
         </p:nvSpPr>
         <p:spPr>
           <a:xfrm>
-            <a:off x="14218920" y="21945600"/>
+            <a:off x="14218920" y="22494240"/>
             <a:ext cx="12435840" cy="365760"/>
           </a:xfrm>
           <a:prstGeom prst="rect">
@@ -4841,7 +4876,7 @@
         </p:nvSpPr>
         <p:spPr>
           <a:xfrm>
-            <a:off x="13898880" y="22905719"/>
+            <a:off x="13898880" y="23454360"/>
             <a:ext cx="13075920" cy="9144000"/>
           </a:xfrm>
           <a:prstGeom prst="roundRect">
@@ -4888,7 +4923,7 @@
         </p:nvSpPr>
         <p:spPr>
           <a:xfrm>
-            <a:off x="14218920" y="23225760"/>
+            <a:off x="14218920" y="23774400"/>
             <a:ext cx="109728" cy="457200"/>
           </a:xfrm>
           <a:prstGeom prst="rect">
@@ -4931,7 +4966,7 @@
         </p:nvSpPr>
         <p:spPr>
           <a:xfrm>
-            <a:off x="14420088" y="23225760"/>
+            <a:off x="14420088" y="23774400"/>
             <a:ext cx="12234672" cy="502920"/>
           </a:xfrm>
           <a:prstGeom prst="rect">
@@ -4967,7 +5002,7 @@
         </p:nvSpPr>
         <p:spPr>
           <a:xfrm>
-            <a:off x="14218920" y="23820119"/>
+            <a:off x="14218920" y="24368760"/>
             <a:ext cx="12435840" cy="1828800"/>
           </a:xfrm>
           <a:prstGeom prst="rect">
@@ -5041,7 +5076,7 @@
         </p:blipFill>
         <p:spPr>
           <a:xfrm>
-            <a:off x="16322040" y="25923239"/>
+            <a:off x="16322040" y="26471880"/>
             <a:ext cx="8229600" cy="7298209"/>
           </a:xfrm>
           <a:prstGeom prst="rect">
@@ -5057,7 +5092,7 @@
         </p:nvSpPr>
         <p:spPr>
           <a:xfrm>
-            <a:off x="14218920" y="32324039"/>
+            <a:off x="14218920" y="32872680"/>
             <a:ext cx="12435840" cy="365760"/>
           </a:xfrm>
           <a:prstGeom prst="rect">
@@ -5093,7 +5128,7 @@
         </p:nvSpPr>
         <p:spPr>
           <a:xfrm>
-            <a:off x="13898880" y="32369760"/>
+            <a:off x="13898880" y="32918400"/>
             <a:ext cx="13075920" cy="3474720"/>
           </a:xfrm>
           <a:prstGeom prst="roundRect">
@@ -5140,7 +5175,7 @@
         </p:nvSpPr>
         <p:spPr>
           <a:xfrm>
-            <a:off x="14218920" y="32689800"/>
+            <a:off x="14218920" y="33238440"/>
             <a:ext cx="109728" cy="457200"/>
           </a:xfrm>
           <a:prstGeom prst="rect">
@@ -5183,7 +5218,7 @@
         </p:nvSpPr>
         <p:spPr>
           <a:xfrm>
-            <a:off x="14420088" y="32689800"/>
+            <a:off x="14420088" y="33238440"/>
             <a:ext cx="12234672" cy="502920"/>
           </a:xfrm>
           <a:prstGeom prst="rect">
@@ -5219,7 +5254,7 @@
         </p:nvSpPr>
         <p:spPr>
           <a:xfrm>
-            <a:off x="14218920" y="33284160"/>
+            <a:off x="14218920" y="33832800"/>
             <a:ext cx="12435840" cy="2377439"/>
           </a:xfrm>
           <a:prstGeom prst="rect">
@@ -5245,7 +5280,7 @@
               </a:defRPr>
             </a:pPr>
             <a:r>
-              <a:t>•   Binary metrics are insufficient at 0.5% positive rate —</a:t>
+              <a:t>•   Binary metrics are insufficient at 0.5% positive rate;</a:t>
             </a:r>
             <a:br/>
             <a:r>
@@ -5308,8 +5343,8 @@
         </p:nvSpPr>
         <p:spPr>
           <a:xfrm>
-            <a:off x="13898880" y="36164520"/>
-            <a:ext cx="13075920" cy="-45719"/>
+            <a:off x="13898880" y="36713160"/>
+            <a:ext cx="13075920" cy="-594360"/>
           </a:xfrm>
           <a:prstGeom prst="roundRect">
             <a:avLst>
@@ -5355,7 +5390,7 @@
         </p:nvSpPr>
         <p:spPr>
           <a:xfrm>
-            <a:off x="14218920" y="36484560"/>
+            <a:off x="14218920" y="37033200"/>
             <a:ext cx="109728" cy="457200"/>
           </a:xfrm>
           <a:prstGeom prst="rect">
@@ -5398,7 +5433,7 @@
         </p:nvSpPr>
         <p:spPr>
           <a:xfrm>
-            <a:off x="14420088" y="36484560"/>
+            <a:off x="14420088" y="37033200"/>
             <a:ext cx="12234672" cy="502920"/>
           </a:xfrm>
           <a:prstGeom prst="rect">
@@ -5434,8 +5469,8 @@
         </p:nvSpPr>
         <p:spPr>
           <a:xfrm>
-            <a:off x="14218920" y="37078920"/>
-            <a:ext cx="12435840" cy="-960119"/>
+            <a:off x="14218920" y="37627560"/>
+            <a:ext cx="12435840" cy="-1508760"/>
           </a:xfrm>
           <a:prstGeom prst="rect">
             <a:avLst/>
@@ -5612,7 +5647,7 @@
               </a:defRPr>
             </a:pPr>
             <a:r>
-              <a:t>•   [9–15] Zhang, Ku, Cui, Liao, Kang, Xiao, Jennings</a:t>
+              <a:t>•   [9-15] Zhang, Ku, Cui, Liao, Kang, Xiao, Jennings</a:t>
             </a:r>
           </a:p>
         </p:txBody>

</xml_diff>